<commit_message>
Fix ppr description in doc
</commit_message>
<xml_diff>
--- a/doc/IIDX_Pico_Manual.pptx
+++ b/doc/IIDX_Pico_Manual.pptx
@@ -237,7 +237,7 @@
           <a:p>
             <a:fld id="{99D69C7F-8110-406B-A63E-81EB2EBDFE06}" type="datetimeFigureOut">
               <a:rPr lang="zh-CN" altLang="en-US" smtClean="0"/>
-              <a:t>2025/10/15</a:t>
+              <a:t>2026/4/11</a:t>
             </a:fld>
             <a:endParaRPr lang="zh-CN" altLang="en-US"/>
           </a:p>
@@ -415,7 +415,7 @@
           <a:p>
             <a:fld id="{002F3B7A-C25F-4CE1-8FEE-39C6D6ACD16A}" type="datetimeFigureOut">
               <a:rPr lang="zh-CN" altLang="en-US" smtClean="0"/>
-              <a:t>2025/10/15</a:t>
+              <a:t>2026/4/11</a:t>
             </a:fld>
             <a:endParaRPr lang="zh-CN" altLang="en-US"/>
           </a:p>
@@ -7722,458 +7722,6 @@
       </p:sp>
       <p:sp>
         <p:nvSpPr>
-          <p:cNvPr id="14" name="矩形: 圆角 13">
-            <a:extLst>
-              <a:ext uri="{FF2B5EF4-FFF2-40B4-BE49-F238E27FC236}">
-                <a16:creationId xmlns:a16="http://schemas.microsoft.com/office/drawing/2014/main" id="{B9CC83F5-7D4F-2265-A332-CDFA73EFCCB0}"/>
-              </a:ext>
-            </a:extLst>
-          </p:cNvPr>
-          <p:cNvSpPr/>
-          <p:nvPr/>
-        </p:nvSpPr>
-        <p:spPr>
-          <a:xfrm>
-            <a:off x="6705666" y="3792143"/>
-            <a:ext cx="694445" cy="1120685"/>
-          </a:xfrm>
-          <a:prstGeom prst="roundRect">
-            <a:avLst>
-              <a:gd name="adj" fmla="val 9697"/>
-            </a:avLst>
-          </a:prstGeom>
-          <a:solidFill>
-            <a:schemeClr val="accent4">
-              <a:lumMod val="75000"/>
-              <a:alpha val="30196"/>
-            </a:schemeClr>
-          </a:solidFill>
-          <a:ln>
-            <a:noFill/>
-          </a:ln>
-        </p:spPr>
-        <p:style>
-          <a:lnRef idx="2">
-            <a:schemeClr val="accent1">
-              <a:shade val="50000"/>
-            </a:schemeClr>
-          </a:lnRef>
-          <a:fillRef idx="1">
-            <a:schemeClr val="accent1"/>
-          </a:fillRef>
-          <a:effectRef idx="0">
-            <a:schemeClr val="accent1"/>
-          </a:effectRef>
-          <a:fontRef idx="minor">
-            <a:schemeClr val="lt1"/>
-          </a:fontRef>
-        </p:style>
-        <p:txBody>
-          <a:bodyPr lIns="0" rIns="0" rtlCol="0" anchor="b"/>
-          <a:lstStyle/>
-          <a:p>
-            <a:pPr algn="ctr">
-              <a:lnSpc>
-                <a:spcPct val="80000"/>
-              </a:lnSpc>
-            </a:pPr>
-            <a:r>
-              <a:rPr lang="en-US" altLang="zh-CN" sz="1100" b="1" dirty="0">
-                <a:solidFill>
-                  <a:schemeClr val="bg1"/>
-                </a:solidFill>
-                <a:highlight>
-                  <a:srgbClr val="808080"/>
-                </a:highlight>
-              </a:rPr>
-              <a:t>256</a:t>
-            </a:r>
-            <a:r>
-              <a:rPr lang="en-US" altLang="zh-CN" sz="1100" b="1" spc="100" dirty="0">
-                <a:solidFill>
-                  <a:srgbClr val="BF9000"/>
-                </a:solidFill>
-              </a:rPr>
-              <a:t>/</a:t>
-            </a:r>
-            <a:r>
-              <a:rPr lang="en-US" altLang="zh-CN" sz="1100" b="1" dirty="0">
-                <a:solidFill>
-                  <a:srgbClr val="0083E6"/>
-                </a:solidFill>
-              </a:rPr>
-              <a:t>200</a:t>
-            </a:r>
-            <a:br>
-              <a:rPr lang="en-US" altLang="zh-CN" sz="1400" b="1" dirty="0">
-                <a:solidFill>
-                  <a:schemeClr val="accent4">
-                    <a:lumMod val="75000"/>
-                  </a:schemeClr>
-                </a:solidFill>
-              </a:rPr>
-            </a:br>
-            <a:r>
-              <a:rPr lang="en-US" altLang="zh-CN" sz="1300" b="1" dirty="0">
-                <a:solidFill>
-                  <a:schemeClr val="accent4">
-                    <a:lumMod val="75000"/>
-                  </a:schemeClr>
-                </a:solidFill>
-              </a:rPr>
-              <a:t>ppr</a:t>
-            </a:r>
-            <a:endParaRPr lang="zh-CN" altLang="en-US" sz="1300" b="1" dirty="0">
-              <a:solidFill>
-                <a:schemeClr val="accent4">
-                  <a:lumMod val="75000"/>
-                </a:schemeClr>
-              </a:solidFill>
-            </a:endParaRPr>
-          </a:p>
-        </p:txBody>
-      </p:sp>
-      <p:sp>
-        <p:nvSpPr>
-          <p:cNvPr id="15" name="矩形: 圆角 14">
-            <a:extLst>
-              <a:ext uri="{FF2B5EF4-FFF2-40B4-BE49-F238E27FC236}">
-                <a16:creationId xmlns:a16="http://schemas.microsoft.com/office/drawing/2014/main" id="{8E4759B0-CB72-A8C2-33DC-C569726D45E0}"/>
-              </a:ext>
-            </a:extLst>
-          </p:cNvPr>
-          <p:cNvSpPr/>
-          <p:nvPr/>
-        </p:nvSpPr>
-        <p:spPr>
-          <a:xfrm>
-            <a:off x="7712792" y="3795426"/>
-            <a:ext cx="694445" cy="1120685"/>
-          </a:xfrm>
-          <a:prstGeom prst="roundRect">
-            <a:avLst>
-              <a:gd name="adj" fmla="val 9697"/>
-            </a:avLst>
-          </a:prstGeom>
-          <a:solidFill>
-            <a:schemeClr val="accent4">
-              <a:lumMod val="75000"/>
-              <a:alpha val="30196"/>
-            </a:schemeClr>
-          </a:solidFill>
-          <a:ln>
-            <a:noFill/>
-          </a:ln>
-        </p:spPr>
-        <p:style>
-          <a:lnRef idx="2">
-            <a:schemeClr val="accent1">
-              <a:shade val="50000"/>
-            </a:schemeClr>
-          </a:lnRef>
-          <a:fillRef idx="1">
-            <a:schemeClr val="accent1"/>
-          </a:fillRef>
-          <a:effectRef idx="0">
-            <a:schemeClr val="accent1"/>
-          </a:effectRef>
-          <a:fontRef idx="minor">
-            <a:schemeClr val="lt1"/>
-          </a:fontRef>
-        </p:style>
-        <p:txBody>
-          <a:bodyPr lIns="0" rIns="0" rtlCol="0" anchor="b"/>
-          <a:lstStyle/>
-          <a:p>
-            <a:pPr algn="ctr">
-              <a:lnSpc>
-                <a:spcPct val="80000"/>
-              </a:lnSpc>
-            </a:pPr>
-            <a:r>
-              <a:rPr lang="en-US" altLang="zh-CN" sz="1100" b="1" dirty="0">
-                <a:solidFill>
-                  <a:schemeClr val="bg1"/>
-                </a:solidFill>
-                <a:highlight>
-                  <a:srgbClr val="808080"/>
-                </a:highlight>
-              </a:rPr>
-              <a:t>160</a:t>
-            </a:r>
-            <a:r>
-              <a:rPr lang="en-US" altLang="zh-CN" sz="1100" b="1" dirty="0">
-                <a:solidFill>
-                  <a:srgbClr val="BF9000"/>
-                </a:solidFill>
-              </a:rPr>
-              <a:t>/</a:t>
-            </a:r>
-            <a:r>
-              <a:rPr lang="en-US" altLang="zh-CN" sz="1100" b="1" dirty="0">
-                <a:solidFill>
-                  <a:srgbClr val="0083E6"/>
-                </a:solidFill>
-              </a:rPr>
-              <a:t>128</a:t>
-            </a:r>
-            <a:br>
-              <a:rPr lang="en-US" altLang="zh-CN" sz="2400" b="1" dirty="0">
-                <a:solidFill>
-                  <a:schemeClr val="accent4">
-                    <a:lumMod val="75000"/>
-                  </a:schemeClr>
-                </a:solidFill>
-              </a:rPr>
-            </a:br>
-            <a:r>
-              <a:rPr lang="en-US" altLang="zh-CN" sz="1300" b="1" dirty="0">
-                <a:solidFill>
-                  <a:schemeClr val="accent4">
-                    <a:lumMod val="75000"/>
-                  </a:schemeClr>
-                </a:solidFill>
-              </a:rPr>
-              <a:t> ppr</a:t>
-            </a:r>
-            <a:endParaRPr lang="zh-CN" altLang="en-US" sz="1300" b="1" dirty="0">
-              <a:solidFill>
-                <a:schemeClr val="accent4">
-                  <a:lumMod val="75000"/>
-                </a:schemeClr>
-              </a:solidFill>
-            </a:endParaRPr>
-          </a:p>
-        </p:txBody>
-      </p:sp>
-      <p:sp>
-        <p:nvSpPr>
-          <p:cNvPr id="16" name="矩形: 圆角 15">
-            <a:extLst>
-              <a:ext uri="{FF2B5EF4-FFF2-40B4-BE49-F238E27FC236}">
-                <a16:creationId xmlns:a16="http://schemas.microsoft.com/office/drawing/2014/main" id="{7115D501-6945-FD53-2383-7A9884368578}"/>
-              </a:ext>
-            </a:extLst>
-          </p:cNvPr>
-          <p:cNvSpPr/>
-          <p:nvPr/>
-        </p:nvSpPr>
-        <p:spPr>
-          <a:xfrm>
-            <a:off x="8727511" y="3792143"/>
-            <a:ext cx="694445" cy="1120685"/>
-          </a:xfrm>
-          <a:prstGeom prst="roundRect">
-            <a:avLst>
-              <a:gd name="adj" fmla="val 9697"/>
-            </a:avLst>
-          </a:prstGeom>
-          <a:solidFill>
-            <a:schemeClr val="accent4">
-              <a:lumMod val="75000"/>
-              <a:alpha val="30196"/>
-            </a:schemeClr>
-          </a:solidFill>
-          <a:ln>
-            <a:noFill/>
-          </a:ln>
-        </p:spPr>
-        <p:style>
-          <a:lnRef idx="2">
-            <a:schemeClr val="accent1">
-              <a:shade val="50000"/>
-            </a:schemeClr>
-          </a:lnRef>
-          <a:fillRef idx="1">
-            <a:schemeClr val="accent1"/>
-          </a:fillRef>
-          <a:effectRef idx="0">
-            <a:schemeClr val="accent1"/>
-          </a:effectRef>
-          <a:fontRef idx="minor">
-            <a:schemeClr val="lt1"/>
-          </a:fontRef>
-        </p:style>
-        <p:txBody>
-          <a:bodyPr lIns="0" rIns="0" rtlCol="0" anchor="b"/>
-          <a:lstStyle/>
-          <a:p>
-            <a:pPr algn="ctr">
-              <a:lnSpc>
-                <a:spcPct val="80000"/>
-              </a:lnSpc>
-            </a:pPr>
-            <a:r>
-              <a:rPr lang="en-US" altLang="zh-CN" sz="1100" b="1" dirty="0">
-                <a:solidFill>
-                  <a:schemeClr val="bg1"/>
-                </a:solidFill>
-                <a:highlight>
-                  <a:srgbClr val="808080"/>
-                </a:highlight>
-              </a:rPr>
-              <a:t>96</a:t>
-            </a:r>
-            <a:r>
-              <a:rPr lang="en-US" altLang="zh-CN" sz="1100" b="1" dirty="0">
-                <a:solidFill>
-                  <a:srgbClr val="BF9000"/>
-                </a:solidFill>
-              </a:rPr>
-              <a:t>/</a:t>
-            </a:r>
-            <a:r>
-              <a:rPr lang="en-US" altLang="zh-CN" sz="1100" b="1" dirty="0">
-                <a:solidFill>
-                  <a:srgbClr val="0083E6"/>
-                </a:solidFill>
-              </a:rPr>
-              <a:t>64</a:t>
-            </a:r>
-            <a:br>
-              <a:rPr lang="en-US" altLang="zh-CN" sz="1300" b="1" dirty="0">
-                <a:solidFill>
-                  <a:schemeClr val="accent4">
-                    <a:lumMod val="75000"/>
-                  </a:schemeClr>
-                </a:solidFill>
-              </a:rPr>
-            </a:br>
-            <a:r>
-              <a:rPr lang="en-US" altLang="zh-CN" sz="1300" b="1" dirty="0">
-                <a:solidFill>
-                  <a:schemeClr val="accent4">
-                    <a:lumMod val="75000"/>
-                  </a:schemeClr>
-                </a:solidFill>
-              </a:rPr>
-              <a:t>ppr</a:t>
-            </a:r>
-            <a:endParaRPr lang="zh-CN" altLang="en-US" sz="1300" b="1" dirty="0">
-              <a:solidFill>
-                <a:schemeClr val="accent4">
-                  <a:lumMod val="75000"/>
-                </a:schemeClr>
-              </a:solidFill>
-            </a:endParaRPr>
-          </a:p>
-        </p:txBody>
-      </p:sp>
-      <p:sp>
-        <p:nvSpPr>
-          <p:cNvPr id="17" name="矩形: 圆角 16">
-            <a:extLst>
-              <a:ext uri="{FF2B5EF4-FFF2-40B4-BE49-F238E27FC236}">
-                <a16:creationId xmlns:a16="http://schemas.microsoft.com/office/drawing/2014/main" id="{507E036C-D322-C7BB-E76C-ABA763F468C4}"/>
-              </a:ext>
-            </a:extLst>
-          </p:cNvPr>
-          <p:cNvSpPr/>
-          <p:nvPr/>
-        </p:nvSpPr>
-        <p:spPr>
-          <a:xfrm>
-            <a:off x="9734637" y="3792143"/>
-            <a:ext cx="694445" cy="1120685"/>
-          </a:xfrm>
-          <a:prstGeom prst="roundRect">
-            <a:avLst>
-              <a:gd name="adj" fmla="val 9697"/>
-            </a:avLst>
-          </a:prstGeom>
-          <a:solidFill>
-            <a:schemeClr val="accent4">
-              <a:lumMod val="75000"/>
-              <a:alpha val="30196"/>
-            </a:schemeClr>
-          </a:solidFill>
-          <a:ln>
-            <a:noFill/>
-          </a:ln>
-        </p:spPr>
-        <p:style>
-          <a:lnRef idx="2">
-            <a:schemeClr val="accent1">
-              <a:shade val="50000"/>
-            </a:schemeClr>
-          </a:lnRef>
-          <a:fillRef idx="1">
-            <a:schemeClr val="accent1"/>
-          </a:fillRef>
-          <a:effectRef idx="0">
-            <a:schemeClr val="accent1"/>
-          </a:effectRef>
-          <a:fontRef idx="minor">
-            <a:schemeClr val="lt1"/>
-          </a:fontRef>
-        </p:style>
-        <p:txBody>
-          <a:bodyPr lIns="0" rIns="0" rtlCol="0" anchor="b"/>
-          <a:lstStyle/>
-          <a:p>
-            <a:pPr algn="ctr">
-              <a:lnSpc>
-                <a:spcPct val="80000"/>
-              </a:lnSpc>
-            </a:pPr>
-            <a:r>
-              <a:rPr lang="en-US" altLang="zh-CN" sz="1100" b="1" dirty="0">
-                <a:solidFill>
-                  <a:schemeClr val="bg1"/>
-                </a:solidFill>
-                <a:highlight>
-                  <a:srgbClr val="808080"/>
-                </a:highlight>
-              </a:rPr>
-              <a:t>48</a:t>
-            </a:r>
-            <a:r>
-              <a:rPr lang="en-US" altLang="zh-CN" sz="1100" b="1" dirty="0">
-                <a:solidFill>
-                  <a:srgbClr val="BF9000"/>
-                </a:solidFill>
-              </a:rPr>
-              <a:t>/</a:t>
-            </a:r>
-            <a:r>
-              <a:rPr lang="en-US" altLang="zh-CN" sz="1100" b="1" dirty="0">
-                <a:solidFill>
-                  <a:srgbClr val="0083E6"/>
-                </a:solidFill>
-              </a:rPr>
-              <a:t>32</a:t>
-            </a:r>
-            <a:br>
-              <a:rPr lang="en-US" altLang="zh-CN" sz="1300" b="1" dirty="0">
-                <a:solidFill>
-                  <a:schemeClr val="accent4">
-                    <a:lumMod val="75000"/>
-                  </a:schemeClr>
-                </a:solidFill>
-              </a:rPr>
-            </a:br>
-            <a:r>
-              <a:rPr lang="en-US" altLang="zh-CN" sz="1300" b="1" dirty="0">
-                <a:solidFill>
-                  <a:schemeClr val="accent4">
-                    <a:lumMod val="75000"/>
-                  </a:schemeClr>
-                </a:solidFill>
-              </a:rPr>
-              <a:t>ppr</a:t>
-            </a:r>
-            <a:endParaRPr lang="zh-CN" altLang="en-US" sz="1300" b="1" dirty="0">
-              <a:solidFill>
-                <a:schemeClr val="accent4">
-                  <a:lumMod val="75000"/>
-                </a:schemeClr>
-              </a:solidFill>
-            </a:endParaRPr>
-          </a:p>
-        </p:txBody>
-      </p:sp>
-      <p:sp>
-        <p:nvSpPr>
           <p:cNvPr id="2" name="矩形: 圆角 1">
             <a:extLst>
               <a:ext uri="{FF2B5EF4-FFF2-40B4-BE49-F238E27FC236}">
@@ -8546,6 +8094,458 @@
               <a:solidFill>
                 <a:schemeClr val="accent4">
                   <a:lumMod val="50000"/>
+                </a:schemeClr>
+              </a:solidFill>
+            </a:endParaRPr>
+          </a:p>
+        </p:txBody>
+      </p:sp>
+      <p:sp>
+        <p:nvSpPr>
+          <p:cNvPr id="46" name="矩形: 圆角 45">
+            <a:extLst>
+              <a:ext uri="{FF2B5EF4-FFF2-40B4-BE49-F238E27FC236}">
+                <a16:creationId xmlns:a16="http://schemas.microsoft.com/office/drawing/2014/main" id="{650476DD-2BA4-A344-33EE-4D5FF0B96879}"/>
+              </a:ext>
+            </a:extLst>
+          </p:cNvPr>
+          <p:cNvSpPr/>
+          <p:nvPr/>
+        </p:nvSpPr>
+        <p:spPr>
+          <a:xfrm>
+            <a:off x="6705666" y="3792143"/>
+            <a:ext cx="694445" cy="1120685"/>
+          </a:xfrm>
+          <a:prstGeom prst="roundRect">
+            <a:avLst>
+              <a:gd name="adj" fmla="val 9697"/>
+            </a:avLst>
+          </a:prstGeom>
+          <a:solidFill>
+            <a:schemeClr val="accent4">
+              <a:lumMod val="75000"/>
+              <a:alpha val="30196"/>
+            </a:schemeClr>
+          </a:solidFill>
+          <a:ln>
+            <a:noFill/>
+          </a:ln>
+        </p:spPr>
+        <p:style>
+          <a:lnRef idx="2">
+            <a:schemeClr val="accent1">
+              <a:shade val="50000"/>
+            </a:schemeClr>
+          </a:lnRef>
+          <a:fillRef idx="1">
+            <a:schemeClr val="accent1"/>
+          </a:fillRef>
+          <a:effectRef idx="0">
+            <a:schemeClr val="accent1"/>
+          </a:effectRef>
+          <a:fontRef idx="minor">
+            <a:schemeClr val="lt1"/>
+          </a:fontRef>
+        </p:style>
+        <p:txBody>
+          <a:bodyPr lIns="0" rIns="0" rtlCol="0" anchor="b"/>
+          <a:lstStyle/>
+          <a:p>
+            <a:pPr algn="ctr">
+              <a:lnSpc>
+                <a:spcPct val="80000"/>
+              </a:lnSpc>
+            </a:pPr>
+            <a:r>
+              <a:rPr lang="en-US" altLang="zh-CN" sz="1100" b="1" dirty="0">
+                <a:solidFill>
+                  <a:srgbClr val="0083E6"/>
+                </a:solidFill>
+              </a:rPr>
+              <a:t>256</a:t>
+            </a:r>
+            <a:r>
+              <a:rPr lang="en-US" altLang="zh-CN" sz="1100" b="1" spc="100" dirty="0">
+                <a:solidFill>
+                  <a:srgbClr val="BF9000"/>
+                </a:solidFill>
+              </a:rPr>
+              <a:t>/</a:t>
+            </a:r>
+            <a:r>
+              <a:rPr lang="en-US" altLang="zh-CN" sz="1100" b="1" dirty="0">
+                <a:solidFill>
+                  <a:schemeClr val="bg1"/>
+                </a:solidFill>
+                <a:highlight>
+                  <a:srgbClr val="808080"/>
+                </a:highlight>
+              </a:rPr>
+              <a:t>200</a:t>
+            </a:r>
+            <a:br>
+              <a:rPr lang="en-US" altLang="zh-CN" sz="1400" b="1" dirty="0">
+                <a:solidFill>
+                  <a:schemeClr val="accent4">
+                    <a:lumMod val="75000"/>
+                  </a:schemeClr>
+                </a:solidFill>
+              </a:rPr>
+            </a:br>
+            <a:r>
+              <a:rPr lang="en-US" altLang="zh-CN" sz="1300" b="1" dirty="0">
+                <a:solidFill>
+                  <a:schemeClr val="accent4">
+                    <a:lumMod val="75000"/>
+                  </a:schemeClr>
+                </a:solidFill>
+              </a:rPr>
+              <a:t>ppr</a:t>
+            </a:r>
+            <a:endParaRPr lang="zh-CN" altLang="en-US" sz="1300" b="1" dirty="0">
+              <a:solidFill>
+                <a:schemeClr val="accent4">
+                  <a:lumMod val="75000"/>
+                </a:schemeClr>
+              </a:solidFill>
+            </a:endParaRPr>
+          </a:p>
+        </p:txBody>
+      </p:sp>
+      <p:sp>
+        <p:nvSpPr>
+          <p:cNvPr id="47" name="矩形: 圆角 46">
+            <a:extLst>
+              <a:ext uri="{FF2B5EF4-FFF2-40B4-BE49-F238E27FC236}">
+                <a16:creationId xmlns:a16="http://schemas.microsoft.com/office/drawing/2014/main" id="{68E33827-CBBD-EB7A-2834-3E3A7527CDD3}"/>
+              </a:ext>
+            </a:extLst>
+          </p:cNvPr>
+          <p:cNvSpPr/>
+          <p:nvPr/>
+        </p:nvSpPr>
+        <p:spPr>
+          <a:xfrm>
+            <a:off x="7712792" y="3795426"/>
+            <a:ext cx="694445" cy="1120685"/>
+          </a:xfrm>
+          <a:prstGeom prst="roundRect">
+            <a:avLst>
+              <a:gd name="adj" fmla="val 9697"/>
+            </a:avLst>
+          </a:prstGeom>
+          <a:solidFill>
+            <a:schemeClr val="accent4">
+              <a:lumMod val="75000"/>
+              <a:alpha val="30196"/>
+            </a:schemeClr>
+          </a:solidFill>
+          <a:ln>
+            <a:noFill/>
+          </a:ln>
+        </p:spPr>
+        <p:style>
+          <a:lnRef idx="2">
+            <a:schemeClr val="accent1">
+              <a:shade val="50000"/>
+            </a:schemeClr>
+          </a:lnRef>
+          <a:fillRef idx="1">
+            <a:schemeClr val="accent1"/>
+          </a:fillRef>
+          <a:effectRef idx="0">
+            <a:schemeClr val="accent1"/>
+          </a:effectRef>
+          <a:fontRef idx="minor">
+            <a:schemeClr val="lt1"/>
+          </a:fontRef>
+        </p:style>
+        <p:txBody>
+          <a:bodyPr lIns="0" rIns="0" rtlCol="0" anchor="b"/>
+          <a:lstStyle/>
+          <a:p>
+            <a:pPr algn="ctr">
+              <a:lnSpc>
+                <a:spcPct val="80000"/>
+              </a:lnSpc>
+            </a:pPr>
+            <a:r>
+              <a:rPr lang="en-US" altLang="zh-CN" sz="1100" b="1" dirty="0">
+                <a:solidFill>
+                  <a:srgbClr val="0083E6"/>
+                </a:solidFill>
+              </a:rPr>
+              <a:t>160</a:t>
+            </a:r>
+            <a:r>
+              <a:rPr lang="en-US" altLang="zh-CN" sz="1100" b="1" dirty="0">
+                <a:solidFill>
+                  <a:srgbClr val="BF9000"/>
+                </a:solidFill>
+              </a:rPr>
+              <a:t>/</a:t>
+            </a:r>
+            <a:r>
+              <a:rPr lang="en-US" altLang="zh-CN" sz="1100" b="1" dirty="0">
+                <a:solidFill>
+                  <a:schemeClr val="bg1"/>
+                </a:solidFill>
+                <a:highlight>
+                  <a:srgbClr val="808080"/>
+                </a:highlight>
+              </a:rPr>
+              <a:t>128</a:t>
+            </a:r>
+            <a:br>
+              <a:rPr lang="en-US" altLang="zh-CN" sz="2400" b="1" dirty="0">
+                <a:solidFill>
+                  <a:schemeClr val="accent4">
+                    <a:lumMod val="75000"/>
+                  </a:schemeClr>
+                </a:solidFill>
+              </a:rPr>
+            </a:br>
+            <a:r>
+              <a:rPr lang="en-US" altLang="zh-CN" sz="1300" b="1" dirty="0">
+                <a:solidFill>
+                  <a:schemeClr val="accent4">
+                    <a:lumMod val="75000"/>
+                  </a:schemeClr>
+                </a:solidFill>
+              </a:rPr>
+              <a:t> ppr</a:t>
+            </a:r>
+            <a:endParaRPr lang="zh-CN" altLang="en-US" sz="1300" b="1" dirty="0">
+              <a:solidFill>
+                <a:schemeClr val="accent4">
+                  <a:lumMod val="75000"/>
+                </a:schemeClr>
+              </a:solidFill>
+            </a:endParaRPr>
+          </a:p>
+        </p:txBody>
+      </p:sp>
+      <p:sp>
+        <p:nvSpPr>
+          <p:cNvPr id="49" name="矩形: 圆角 48">
+            <a:extLst>
+              <a:ext uri="{FF2B5EF4-FFF2-40B4-BE49-F238E27FC236}">
+                <a16:creationId xmlns:a16="http://schemas.microsoft.com/office/drawing/2014/main" id="{DA401C93-BB4D-2B72-8B1C-9B3A8BEF2646}"/>
+              </a:ext>
+            </a:extLst>
+          </p:cNvPr>
+          <p:cNvSpPr/>
+          <p:nvPr/>
+        </p:nvSpPr>
+        <p:spPr>
+          <a:xfrm>
+            <a:off x="8727511" y="3792143"/>
+            <a:ext cx="694445" cy="1120685"/>
+          </a:xfrm>
+          <a:prstGeom prst="roundRect">
+            <a:avLst>
+              <a:gd name="adj" fmla="val 9697"/>
+            </a:avLst>
+          </a:prstGeom>
+          <a:solidFill>
+            <a:schemeClr val="accent4">
+              <a:lumMod val="75000"/>
+              <a:alpha val="30196"/>
+            </a:schemeClr>
+          </a:solidFill>
+          <a:ln>
+            <a:noFill/>
+          </a:ln>
+        </p:spPr>
+        <p:style>
+          <a:lnRef idx="2">
+            <a:schemeClr val="accent1">
+              <a:shade val="50000"/>
+            </a:schemeClr>
+          </a:lnRef>
+          <a:fillRef idx="1">
+            <a:schemeClr val="accent1"/>
+          </a:fillRef>
+          <a:effectRef idx="0">
+            <a:schemeClr val="accent1"/>
+          </a:effectRef>
+          <a:fontRef idx="minor">
+            <a:schemeClr val="lt1"/>
+          </a:fontRef>
+        </p:style>
+        <p:txBody>
+          <a:bodyPr lIns="0" rIns="0" rtlCol="0" anchor="b"/>
+          <a:lstStyle/>
+          <a:p>
+            <a:pPr algn="ctr">
+              <a:lnSpc>
+                <a:spcPct val="80000"/>
+              </a:lnSpc>
+            </a:pPr>
+            <a:r>
+              <a:rPr lang="en-US" altLang="zh-CN" sz="1100" b="1" dirty="0">
+                <a:solidFill>
+                  <a:srgbClr val="0083E6"/>
+                </a:solidFill>
+              </a:rPr>
+              <a:t>96</a:t>
+            </a:r>
+            <a:r>
+              <a:rPr lang="en-US" altLang="zh-CN" sz="1100" b="1" dirty="0">
+                <a:solidFill>
+                  <a:srgbClr val="BF9000"/>
+                </a:solidFill>
+              </a:rPr>
+              <a:t>/</a:t>
+            </a:r>
+            <a:r>
+              <a:rPr lang="en-US" altLang="zh-CN" sz="1100" b="1" dirty="0">
+                <a:solidFill>
+                  <a:schemeClr val="bg1"/>
+                </a:solidFill>
+                <a:highlight>
+                  <a:srgbClr val="808080"/>
+                </a:highlight>
+              </a:rPr>
+              <a:t>64</a:t>
+            </a:r>
+            <a:br>
+              <a:rPr lang="en-US" altLang="zh-CN" sz="1300" b="1" dirty="0">
+                <a:solidFill>
+                  <a:schemeClr val="accent4">
+                    <a:lumMod val="75000"/>
+                  </a:schemeClr>
+                </a:solidFill>
+              </a:rPr>
+            </a:br>
+            <a:r>
+              <a:rPr lang="en-US" altLang="zh-CN" sz="1300" b="1" dirty="0">
+                <a:solidFill>
+                  <a:schemeClr val="accent4">
+                    <a:lumMod val="75000"/>
+                  </a:schemeClr>
+                </a:solidFill>
+              </a:rPr>
+              <a:t>ppr</a:t>
+            </a:r>
+            <a:endParaRPr lang="zh-CN" altLang="en-US" sz="1300" b="1" dirty="0">
+              <a:solidFill>
+                <a:schemeClr val="accent4">
+                  <a:lumMod val="75000"/>
+                </a:schemeClr>
+              </a:solidFill>
+            </a:endParaRPr>
+          </a:p>
+        </p:txBody>
+      </p:sp>
+      <p:sp>
+        <p:nvSpPr>
+          <p:cNvPr id="50" name="矩形: 圆角 49">
+            <a:extLst>
+              <a:ext uri="{FF2B5EF4-FFF2-40B4-BE49-F238E27FC236}">
+                <a16:creationId xmlns:a16="http://schemas.microsoft.com/office/drawing/2014/main" id="{7B279600-4AF4-2BB1-F621-683637B2E8B9}"/>
+              </a:ext>
+            </a:extLst>
+          </p:cNvPr>
+          <p:cNvSpPr/>
+          <p:nvPr/>
+        </p:nvSpPr>
+        <p:spPr>
+          <a:xfrm>
+            <a:off x="9734637" y="3792143"/>
+            <a:ext cx="694445" cy="1120685"/>
+          </a:xfrm>
+          <a:prstGeom prst="roundRect">
+            <a:avLst>
+              <a:gd name="adj" fmla="val 9697"/>
+            </a:avLst>
+          </a:prstGeom>
+          <a:solidFill>
+            <a:schemeClr val="accent4">
+              <a:lumMod val="75000"/>
+              <a:alpha val="30196"/>
+            </a:schemeClr>
+          </a:solidFill>
+          <a:ln>
+            <a:noFill/>
+          </a:ln>
+        </p:spPr>
+        <p:style>
+          <a:lnRef idx="2">
+            <a:schemeClr val="accent1">
+              <a:shade val="50000"/>
+            </a:schemeClr>
+          </a:lnRef>
+          <a:fillRef idx="1">
+            <a:schemeClr val="accent1"/>
+          </a:fillRef>
+          <a:effectRef idx="0">
+            <a:schemeClr val="accent1"/>
+          </a:effectRef>
+          <a:fontRef idx="minor">
+            <a:schemeClr val="lt1"/>
+          </a:fontRef>
+        </p:style>
+        <p:txBody>
+          <a:bodyPr lIns="0" rIns="0" rtlCol="0" anchor="b"/>
+          <a:lstStyle/>
+          <a:p>
+            <a:pPr algn="ctr">
+              <a:lnSpc>
+                <a:spcPct val="80000"/>
+              </a:lnSpc>
+            </a:pPr>
+            <a:r>
+              <a:rPr lang="en-US" altLang="zh-CN" sz="1100" b="1" dirty="0">
+                <a:solidFill>
+                  <a:srgbClr val="0083E6"/>
+                </a:solidFill>
+              </a:rPr>
+              <a:t>48</a:t>
+            </a:r>
+            <a:r>
+              <a:rPr lang="en-US" altLang="zh-CN" sz="1100" b="1" dirty="0">
+                <a:solidFill>
+                  <a:srgbClr val="BF9000"/>
+                </a:solidFill>
+              </a:rPr>
+              <a:t>/</a:t>
+            </a:r>
+            <a:r>
+              <a:rPr lang="en-US" altLang="zh-CN" sz="1100" b="1" dirty="0">
+                <a:solidFill>
+                  <a:schemeClr val="bg1"/>
+                </a:solidFill>
+                <a:highlight>
+                  <a:srgbClr val="808080"/>
+                </a:highlight>
+              </a:rPr>
+              <a:t>32</a:t>
+            </a:r>
+            <a:br>
+              <a:rPr lang="en-US" altLang="zh-CN" sz="1300" b="1" dirty="0">
+                <a:solidFill>
+                  <a:schemeClr val="accent4">
+                    <a:lumMod val="75000"/>
+                  </a:schemeClr>
+                </a:solidFill>
+              </a:rPr>
+            </a:br>
+            <a:r>
+              <a:rPr lang="en-US" altLang="zh-CN" sz="1300" b="1" dirty="0">
+                <a:solidFill>
+                  <a:schemeClr val="accent4">
+                    <a:lumMod val="75000"/>
+                  </a:schemeClr>
+                </a:solidFill>
+              </a:rPr>
+              <a:t>ppr</a:t>
+            </a:r>
+            <a:endParaRPr lang="zh-CN" altLang="en-US" sz="1300" b="1" dirty="0">
+              <a:solidFill>
+                <a:schemeClr val="accent4">
+                  <a:lumMod val="75000"/>
                 </a:schemeClr>
               </a:solidFill>
             </a:endParaRPr>
@@ -16586,458 +16586,6 @@
       </p:sp>
       <p:sp>
         <p:nvSpPr>
-          <p:cNvPr id="14" name="矩形: 圆角 13">
-            <a:extLst>
-              <a:ext uri="{FF2B5EF4-FFF2-40B4-BE49-F238E27FC236}">
-                <a16:creationId xmlns:a16="http://schemas.microsoft.com/office/drawing/2014/main" id="{4DA506B6-6E6D-E22C-B2EF-71C38B372973}"/>
-              </a:ext>
-            </a:extLst>
-          </p:cNvPr>
-          <p:cNvSpPr/>
-          <p:nvPr/>
-        </p:nvSpPr>
-        <p:spPr>
-          <a:xfrm>
-            <a:off x="6705666" y="3792143"/>
-            <a:ext cx="694445" cy="1120685"/>
-          </a:xfrm>
-          <a:prstGeom prst="roundRect">
-            <a:avLst>
-              <a:gd name="adj" fmla="val 9697"/>
-            </a:avLst>
-          </a:prstGeom>
-          <a:solidFill>
-            <a:schemeClr val="accent4">
-              <a:lumMod val="75000"/>
-              <a:alpha val="30196"/>
-            </a:schemeClr>
-          </a:solidFill>
-          <a:ln>
-            <a:noFill/>
-          </a:ln>
-        </p:spPr>
-        <p:style>
-          <a:lnRef idx="2">
-            <a:schemeClr val="accent1">
-              <a:shade val="50000"/>
-            </a:schemeClr>
-          </a:lnRef>
-          <a:fillRef idx="1">
-            <a:schemeClr val="accent1"/>
-          </a:fillRef>
-          <a:effectRef idx="0">
-            <a:schemeClr val="accent1"/>
-          </a:effectRef>
-          <a:fontRef idx="minor">
-            <a:schemeClr val="lt1"/>
-          </a:fontRef>
-        </p:style>
-        <p:txBody>
-          <a:bodyPr lIns="0" rIns="0" rtlCol="0" anchor="b"/>
-          <a:lstStyle/>
-          <a:p>
-            <a:pPr algn="ctr">
-              <a:lnSpc>
-                <a:spcPct val="80000"/>
-              </a:lnSpc>
-            </a:pPr>
-            <a:r>
-              <a:rPr lang="en-US" altLang="zh-CN" sz="1100" b="1" dirty="0">
-                <a:solidFill>
-                  <a:schemeClr val="bg1"/>
-                </a:solidFill>
-                <a:highlight>
-                  <a:srgbClr val="808080"/>
-                </a:highlight>
-              </a:rPr>
-              <a:t>256</a:t>
-            </a:r>
-            <a:r>
-              <a:rPr lang="en-US" altLang="zh-CN" sz="1100" b="1" spc="100" dirty="0">
-                <a:solidFill>
-                  <a:srgbClr val="BF9000"/>
-                </a:solidFill>
-              </a:rPr>
-              <a:t>/</a:t>
-            </a:r>
-            <a:r>
-              <a:rPr lang="en-US" altLang="zh-CN" sz="1100" b="1" dirty="0">
-                <a:solidFill>
-                  <a:srgbClr val="0083E6"/>
-                </a:solidFill>
-              </a:rPr>
-              <a:t>200</a:t>
-            </a:r>
-            <a:br>
-              <a:rPr lang="en-US" altLang="zh-CN" sz="1400" b="1" dirty="0">
-                <a:solidFill>
-                  <a:schemeClr val="accent4">
-                    <a:lumMod val="75000"/>
-                  </a:schemeClr>
-                </a:solidFill>
-              </a:rPr>
-            </a:br>
-            <a:r>
-              <a:rPr lang="en-US" altLang="zh-CN" sz="1300" b="1" dirty="0">
-                <a:solidFill>
-                  <a:schemeClr val="accent4">
-                    <a:lumMod val="75000"/>
-                  </a:schemeClr>
-                </a:solidFill>
-              </a:rPr>
-              <a:t>ppr</a:t>
-            </a:r>
-            <a:endParaRPr lang="zh-CN" altLang="en-US" sz="1300" b="1" dirty="0">
-              <a:solidFill>
-                <a:schemeClr val="accent4">
-                  <a:lumMod val="75000"/>
-                </a:schemeClr>
-              </a:solidFill>
-            </a:endParaRPr>
-          </a:p>
-        </p:txBody>
-      </p:sp>
-      <p:sp>
-        <p:nvSpPr>
-          <p:cNvPr id="15" name="矩形: 圆角 14">
-            <a:extLst>
-              <a:ext uri="{FF2B5EF4-FFF2-40B4-BE49-F238E27FC236}">
-                <a16:creationId xmlns:a16="http://schemas.microsoft.com/office/drawing/2014/main" id="{5E185BFC-D1EC-680E-75E8-5E16219C9634}"/>
-              </a:ext>
-            </a:extLst>
-          </p:cNvPr>
-          <p:cNvSpPr/>
-          <p:nvPr/>
-        </p:nvSpPr>
-        <p:spPr>
-          <a:xfrm>
-            <a:off x="7712792" y="3795426"/>
-            <a:ext cx="694445" cy="1120685"/>
-          </a:xfrm>
-          <a:prstGeom prst="roundRect">
-            <a:avLst>
-              <a:gd name="adj" fmla="val 9697"/>
-            </a:avLst>
-          </a:prstGeom>
-          <a:solidFill>
-            <a:schemeClr val="accent4">
-              <a:lumMod val="75000"/>
-              <a:alpha val="30196"/>
-            </a:schemeClr>
-          </a:solidFill>
-          <a:ln>
-            <a:noFill/>
-          </a:ln>
-        </p:spPr>
-        <p:style>
-          <a:lnRef idx="2">
-            <a:schemeClr val="accent1">
-              <a:shade val="50000"/>
-            </a:schemeClr>
-          </a:lnRef>
-          <a:fillRef idx="1">
-            <a:schemeClr val="accent1"/>
-          </a:fillRef>
-          <a:effectRef idx="0">
-            <a:schemeClr val="accent1"/>
-          </a:effectRef>
-          <a:fontRef idx="minor">
-            <a:schemeClr val="lt1"/>
-          </a:fontRef>
-        </p:style>
-        <p:txBody>
-          <a:bodyPr lIns="0" rIns="0" rtlCol="0" anchor="b"/>
-          <a:lstStyle/>
-          <a:p>
-            <a:pPr algn="ctr">
-              <a:lnSpc>
-                <a:spcPct val="80000"/>
-              </a:lnSpc>
-            </a:pPr>
-            <a:r>
-              <a:rPr lang="en-US" altLang="zh-CN" sz="1100" b="1" dirty="0">
-                <a:solidFill>
-                  <a:schemeClr val="bg1"/>
-                </a:solidFill>
-                <a:highlight>
-                  <a:srgbClr val="808080"/>
-                </a:highlight>
-              </a:rPr>
-              <a:t>160</a:t>
-            </a:r>
-            <a:r>
-              <a:rPr lang="en-US" altLang="zh-CN" sz="1100" b="1" dirty="0">
-                <a:solidFill>
-                  <a:srgbClr val="BF9000"/>
-                </a:solidFill>
-              </a:rPr>
-              <a:t>/</a:t>
-            </a:r>
-            <a:r>
-              <a:rPr lang="en-US" altLang="zh-CN" sz="1100" b="1" dirty="0">
-                <a:solidFill>
-                  <a:srgbClr val="0083E6"/>
-                </a:solidFill>
-              </a:rPr>
-              <a:t>128</a:t>
-            </a:r>
-            <a:br>
-              <a:rPr lang="en-US" altLang="zh-CN" sz="2400" b="1" dirty="0">
-                <a:solidFill>
-                  <a:schemeClr val="accent4">
-                    <a:lumMod val="75000"/>
-                  </a:schemeClr>
-                </a:solidFill>
-              </a:rPr>
-            </a:br>
-            <a:r>
-              <a:rPr lang="en-US" altLang="zh-CN" sz="1300" b="1" dirty="0">
-                <a:solidFill>
-                  <a:schemeClr val="accent4">
-                    <a:lumMod val="75000"/>
-                  </a:schemeClr>
-                </a:solidFill>
-              </a:rPr>
-              <a:t> ppr</a:t>
-            </a:r>
-            <a:endParaRPr lang="zh-CN" altLang="en-US" sz="1300" b="1" dirty="0">
-              <a:solidFill>
-                <a:schemeClr val="accent4">
-                  <a:lumMod val="75000"/>
-                </a:schemeClr>
-              </a:solidFill>
-            </a:endParaRPr>
-          </a:p>
-        </p:txBody>
-      </p:sp>
-      <p:sp>
-        <p:nvSpPr>
-          <p:cNvPr id="16" name="矩形: 圆角 15">
-            <a:extLst>
-              <a:ext uri="{FF2B5EF4-FFF2-40B4-BE49-F238E27FC236}">
-                <a16:creationId xmlns:a16="http://schemas.microsoft.com/office/drawing/2014/main" id="{EFBB42F4-83D3-A4AC-304D-D31A4F68E6E1}"/>
-              </a:ext>
-            </a:extLst>
-          </p:cNvPr>
-          <p:cNvSpPr/>
-          <p:nvPr/>
-        </p:nvSpPr>
-        <p:spPr>
-          <a:xfrm>
-            <a:off x="8727511" y="3792143"/>
-            <a:ext cx="694445" cy="1120685"/>
-          </a:xfrm>
-          <a:prstGeom prst="roundRect">
-            <a:avLst>
-              <a:gd name="adj" fmla="val 9697"/>
-            </a:avLst>
-          </a:prstGeom>
-          <a:solidFill>
-            <a:schemeClr val="accent4">
-              <a:lumMod val="75000"/>
-              <a:alpha val="30196"/>
-            </a:schemeClr>
-          </a:solidFill>
-          <a:ln>
-            <a:noFill/>
-          </a:ln>
-        </p:spPr>
-        <p:style>
-          <a:lnRef idx="2">
-            <a:schemeClr val="accent1">
-              <a:shade val="50000"/>
-            </a:schemeClr>
-          </a:lnRef>
-          <a:fillRef idx="1">
-            <a:schemeClr val="accent1"/>
-          </a:fillRef>
-          <a:effectRef idx="0">
-            <a:schemeClr val="accent1"/>
-          </a:effectRef>
-          <a:fontRef idx="minor">
-            <a:schemeClr val="lt1"/>
-          </a:fontRef>
-        </p:style>
-        <p:txBody>
-          <a:bodyPr lIns="0" rIns="0" rtlCol="0" anchor="b"/>
-          <a:lstStyle/>
-          <a:p>
-            <a:pPr algn="ctr">
-              <a:lnSpc>
-                <a:spcPct val="80000"/>
-              </a:lnSpc>
-            </a:pPr>
-            <a:r>
-              <a:rPr lang="en-US" altLang="zh-CN" sz="1100" b="1" dirty="0">
-                <a:solidFill>
-                  <a:schemeClr val="bg1"/>
-                </a:solidFill>
-                <a:highlight>
-                  <a:srgbClr val="808080"/>
-                </a:highlight>
-              </a:rPr>
-              <a:t>96</a:t>
-            </a:r>
-            <a:r>
-              <a:rPr lang="en-US" altLang="zh-CN" sz="1100" b="1" dirty="0">
-                <a:solidFill>
-                  <a:srgbClr val="BF9000"/>
-                </a:solidFill>
-              </a:rPr>
-              <a:t>/</a:t>
-            </a:r>
-            <a:r>
-              <a:rPr lang="en-US" altLang="zh-CN" sz="1100" b="1" dirty="0">
-                <a:solidFill>
-                  <a:srgbClr val="0083E6"/>
-                </a:solidFill>
-              </a:rPr>
-              <a:t>64</a:t>
-            </a:r>
-            <a:br>
-              <a:rPr lang="en-US" altLang="zh-CN" sz="1300" b="1" dirty="0">
-                <a:solidFill>
-                  <a:schemeClr val="accent4">
-                    <a:lumMod val="75000"/>
-                  </a:schemeClr>
-                </a:solidFill>
-              </a:rPr>
-            </a:br>
-            <a:r>
-              <a:rPr lang="en-US" altLang="zh-CN" sz="1300" b="1" dirty="0">
-                <a:solidFill>
-                  <a:schemeClr val="accent4">
-                    <a:lumMod val="75000"/>
-                  </a:schemeClr>
-                </a:solidFill>
-              </a:rPr>
-              <a:t>ppr</a:t>
-            </a:r>
-            <a:endParaRPr lang="zh-CN" altLang="en-US" sz="1300" b="1" dirty="0">
-              <a:solidFill>
-                <a:schemeClr val="accent4">
-                  <a:lumMod val="75000"/>
-                </a:schemeClr>
-              </a:solidFill>
-            </a:endParaRPr>
-          </a:p>
-        </p:txBody>
-      </p:sp>
-      <p:sp>
-        <p:nvSpPr>
-          <p:cNvPr id="17" name="矩形: 圆角 16">
-            <a:extLst>
-              <a:ext uri="{FF2B5EF4-FFF2-40B4-BE49-F238E27FC236}">
-                <a16:creationId xmlns:a16="http://schemas.microsoft.com/office/drawing/2014/main" id="{1BF9F78A-D9E7-CD22-A46A-587328ACF5A4}"/>
-              </a:ext>
-            </a:extLst>
-          </p:cNvPr>
-          <p:cNvSpPr/>
-          <p:nvPr/>
-        </p:nvSpPr>
-        <p:spPr>
-          <a:xfrm>
-            <a:off x="9734637" y="3792143"/>
-            <a:ext cx="694445" cy="1120685"/>
-          </a:xfrm>
-          <a:prstGeom prst="roundRect">
-            <a:avLst>
-              <a:gd name="adj" fmla="val 9697"/>
-            </a:avLst>
-          </a:prstGeom>
-          <a:solidFill>
-            <a:schemeClr val="accent4">
-              <a:lumMod val="75000"/>
-              <a:alpha val="30196"/>
-            </a:schemeClr>
-          </a:solidFill>
-          <a:ln>
-            <a:noFill/>
-          </a:ln>
-        </p:spPr>
-        <p:style>
-          <a:lnRef idx="2">
-            <a:schemeClr val="accent1">
-              <a:shade val="50000"/>
-            </a:schemeClr>
-          </a:lnRef>
-          <a:fillRef idx="1">
-            <a:schemeClr val="accent1"/>
-          </a:fillRef>
-          <a:effectRef idx="0">
-            <a:schemeClr val="accent1"/>
-          </a:effectRef>
-          <a:fontRef idx="minor">
-            <a:schemeClr val="lt1"/>
-          </a:fontRef>
-        </p:style>
-        <p:txBody>
-          <a:bodyPr lIns="0" rIns="0" rtlCol="0" anchor="b"/>
-          <a:lstStyle/>
-          <a:p>
-            <a:pPr algn="ctr">
-              <a:lnSpc>
-                <a:spcPct val="80000"/>
-              </a:lnSpc>
-            </a:pPr>
-            <a:r>
-              <a:rPr lang="en-US" altLang="zh-CN" sz="1100" b="1" dirty="0">
-                <a:solidFill>
-                  <a:schemeClr val="bg1"/>
-                </a:solidFill>
-                <a:highlight>
-                  <a:srgbClr val="808080"/>
-                </a:highlight>
-              </a:rPr>
-              <a:t>48</a:t>
-            </a:r>
-            <a:r>
-              <a:rPr lang="en-US" altLang="zh-CN" sz="1100" b="1" dirty="0">
-                <a:solidFill>
-                  <a:srgbClr val="BF9000"/>
-                </a:solidFill>
-              </a:rPr>
-              <a:t>/</a:t>
-            </a:r>
-            <a:r>
-              <a:rPr lang="en-US" altLang="zh-CN" sz="1100" b="1" dirty="0">
-                <a:solidFill>
-                  <a:srgbClr val="0083E6"/>
-                </a:solidFill>
-              </a:rPr>
-              <a:t>32</a:t>
-            </a:r>
-            <a:br>
-              <a:rPr lang="en-US" altLang="zh-CN" sz="1300" b="1" dirty="0">
-                <a:solidFill>
-                  <a:schemeClr val="accent4">
-                    <a:lumMod val="75000"/>
-                  </a:schemeClr>
-                </a:solidFill>
-              </a:rPr>
-            </a:br>
-            <a:r>
-              <a:rPr lang="en-US" altLang="zh-CN" sz="1300" b="1" dirty="0">
-                <a:solidFill>
-                  <a:schemeClr val="accent4">
-                    <a:lumMod val="75000"/>
-                  </a:schemeClr>
-                </a:solidFill>
-              </a:rPr>
-              <a:t>ppr</a:t>
-            </a:r>
-            <a:endParaRPr lang="zh-CN" altLang="en-US" sz="1300" b="1" dirty="0">
-              <a:solidFill>
-                <a:schemeClr val="accent4">
-                  <a:lumMod val="75000"/>
-                </a:schemeClr>
-              </a:solidFill>
-            </a:endParaRPr>
-          </a:p>
-        </p:txBody>
-      </p:sp>
-      <p:sp>
-        <p:nvSpPr>
           <p:cNvPr id="2" name="矩形: 圆角 1">
             <a:extLst>
               <a:ext uri="{FF2B5EF4-FFF2-40B4-BE49-F238E27FC236}">
@@ -17409,6 +16957,458 @@
               <a:solidFill>
                 <a:schemeClr val="accent4">
                   <a:lumMod val="50000"/>
+                </a:schemeClr>
+              </a:solidFill>
+            </a:endParaRPr>
+          </a:p>
+        </p:txBody>
+      </p:sp>
+      <p:sp>
+        <p:nvSpPr>
+          <p:cNvPr id="18" name="矩形: 圆角 17">
+            <a:extLst>
+              <a:ext uri="{FF2B5EF4-FFF2-40B4-BE49-F238E27FC236}">
+                <a16:creationId xmlns:a16="http://schemas.microsoft.com/office/drawing/2014/main" id="{53C0096F-A6A9-62A8-094A-090306318E0D}"/>
+              </a:ext>
+            </a:extLst>
+          </p:cNvPr>
+          <p:cNvSpPr/>
+          <p:nvPr/>
+        </p:nvSpPr>
+        <p:spPr>
+          <a:xfrm>
+            <a:off x="6705666" y="3792143"/>
+            <a:ext cx="694445" cy="1120685"/>
+          </a:xfrm>
+          <a:prstGeom prst="roundRect">
+            <a:avLst>
+              <a:gd name="adj" fmla="val 9697"/>
+            </a:avLst>
+          </a:prstGeom>
+          <a:solidFill>
+            <a:schemeClr val="accent4">
+              <a:lumMod val="75000"/>
+              <a:alpha val="30196"/>
+            </a:schemeClr>
+          </a:solidFill>
+          <a:ln>
+            <a:noFill/>
+          </a:ln>
+        </p:spPr>
+        <p:style>
+          <a:lnRef idx="2">
+            <a:schemeClr val="accent1">
+              <a:shade val="50000"/>
+            </a:schemeClr>
+          </a:lnRef>
+          <a:fillRef idx="1">
+            <a:schemeClr val="accent1"/>
+          </a:fillRef>
+          <a:effectRef idx="0">
+            <a:schemeClr val="accent1"/>
+          </a:effectRef>
+          <a:fontRef idx="minor">
+            <a:schemeClr val="lt1"/>
+          </a:fontRef>
+        </p:style>
+        <p:txBody>
+          <a:bodyPr lIns="0" rIns="0" rtlCol="0" anchor="b"/>
+          <a:lstStyle/>
+          <a:p>
+            <a:pPr algn="ctr">
+              <a:lnSpc>
+                <a:spcPct val="80000"/>
+              </a:lnSpc>
+            </a:pPr>
+            <a:r>
+              <a:rPr lang="en-US" altLang="zh-CN" sz="1100" b="1" dirty="0">
+                <a:solidFill>
+                  <a:srgbClr val="0083E6"/>
+                </a:solidFill>
+              </a:rPr>
+              <a:t>256</a:t>
+            </a:r>
+            <a:r>
+              <a:rPr lang="en-US" altLang="zh-CN" sz="1100" b="1" spc="100" dirty="0">
+                <a:solidFill>
+                  <a:srgbClr val="BF9000"/>
+                </a:solidFill>
+              </a:rPr>
+              <a:t>/</a:t>
+            </a:r>
+            <a:r>
+              <a:rPr lang="en-US" altLang="zh-CN" sz="1100" b="1" dirty="0">
+                <a:solidFill>
+                  <a:schemeClr val="bg1"/>
+                </a:solidFill>
+                <a:highlight>
+                  <a:srgbClr val="808080"/>
+                </a:highlight>
+              </a:rPr>
+              <a:t>200</a:t>
+            </a:r>
+            <a:br>
+              <a:rPr lang="en-US" altLang="zh-CN" sz="1400" b="1" dirty="0">
+                <a:solidFill>
+                  <a:schemeClr val="accent4">
+                    <a:lumMod val="75000"/>
+                  </a:schemeClr>
+                </a:solidFill>
+              </a:rPr>
+            </a:br>
+            <a:r>
+              <a:rPr lang="en-US" altLang="zh-CN" sz="1300" b="1" dirty="0">
+                <a:solidFill>
+                  <a:schemeClr val="accent4">
+                    <a:lumMod val="75000"/>
+                  </a:schemeClr>
+                </a:solidFill>
+              </a:rPr>
+              <a:t>ppr</a:t>
+            </a:r>
+            <a:endParaRPr lang="zh-CN" altLang="en-US" sz="1300" b="1" dirty="0">
+              <a:solidFill>
+                <a:schemeClr val="accent4">
+                  <a:lumMod val="75000"/>
+                </a:schemeClr>
+              </a:solidFill>
+            </a:endParaRPr>
+          </a:p>
+        </p:txBody>
+      </p:sp>
+      <p:sp>
+        <p:nvSpPr>
+          <p:cNvPr id="21" name="矩形: 圆角 20">
+            <a:extLst>
+              <a:ext uri="{FF2B5EF4-FFF2-40B4-BE49-F238E27FC236}">
+                <a16:creationId xmlns:a16="http://schemas.microsoft.com/office/drawing/2014/main" id="{534F57D3-94D9-C1FB-AD9B-74689E327EE9}"/>
+              </a:ext>
+            </a:extLst>
+          </p:cNvPr>
+          <p:cNvSpPr/>
+          <p:nvPr/>
+        </p:nvSpPr>
+        <p:spPr>
+          <a:xfrm>
+            <a:off x="7712792" y="3795426"/>
+            <a:ext cx="694445" cy="1120685"/>
+          </a:xfrm>
+          <a:prstGeom prst="roundRect">
+            <a:avLst>
+              <a:gd name="adj" fmla="val 9697"/>
+            </a:avLst>
+          </a:prstGeom>
+          <a:solidFill>
+            <a:schemeClr val="accent4">
+              <a:lumMod val="75000"/>
+              <a:alpha val="30196"/>
+            </a:schemeClr>
+          </a:solidFill>
+          <a:ln>
+            <a:noFill/>
+          </a:ln>
+        </p:spPr>
+        <p:style>
+          <a:lnRef idx="2">
+            <a:schemeClr val="accent1">
+              <a:shade val="50000"/>
+            </a:schemeClr>
+          </a:lnRef>
+          <a:fillRef idx="1">
+            <a:schemeClr val="accent1"/>
+          </a:fillRef>
+          <a:effectRef idx="0">
+            <a:schemeClr val="accent1"/>
+          </a:effectRef>
+          <a:fontRef idx="minor">
+            <a:schemeClr val="lt1"/>
+          </a:fontRef>
+        </p:style>
+        <p:txBody>
+          <a:bodyPr lIns="0" rIns="0" rtlCol="0" anchor="b"/>
+          <a:lstStyle/>
+          <a:p>
+            <a:pPr algn="ctr">
+              <a:lnSpc>
+                <a:spcPct val="80000"/>
+              </a:lnSpc>
+            </a:pPr>
+            <a:r>
+              <a:rPr lang="en-US" altLang="zh-CN" sz="1100" b="1" dirty="0">
+                <a:solidFill>
+                  <a:srgbClr val="0083E6"/>
+                </a:solidFill>
+              </a:rPr>
+              <a:t>160</a:t>
+            </a:r>
+            <a:r>
+              <a:rPr lang="en-US" altLang="zh-CN" sz="1100" b="1" dirty="0">
+                <a:solidFill>
+                  <a:srgbClr val="BF9000"/>
+                </a:solidFill>
+              </a:rPr>
+              <a:t>/</a:t>
+            </a:r>
+            <a:r>
+              <a:rPr lang="en-US" altLang="zh-CN" sz="1100" b="1" dirty="0">
+                <a:solidFill>
+                  <a:schemeClr val="bg1"/>
+                </a:solidFill>
+                <a:highlight>
+                  <a:srgbClr val="808080"/>
+                </a:highlight>
+              </a:rPr>
+              <a:t>128</a:t>
+            </a:r>
+            <a:br>
+              <a:rPr lang="en-US" altLang="zh-CN" sz="2400" b="1" dirty="0">
+                <a:solidFill>
+                  <a:schemeClr val="accent4">
+                    <a:lumMod val="75000"/>
+                  </a:schemeClr>
+                </a:solidFill>
+              </a:rPr>
+            </a:br>
+            <a:r>
+              <a:rPr lang="en-US" altLang="zh-CN" sz="1300" b="1" dirty="0">
+                <a:solidFill>
+                  <a:schemeClr val="accent4">
+                    <a:lumMod val="75000"/>
+                  </a:schemeClr>
+                </a:solidFill>
+              </a:rPr>
+              <a:t> ppr</a:t>
+            </a:r>
+            <a:endParaRPr lang="zh-CN" altLang="en-US" sz="1300" b="1" dirty="0">
+              <a:solidFill>
+                <a:schemeClr val="accent4">
+                  <a:lumMod val="75000"/>
+                </a:schemeClr>
+              </a:solidFill>
+            </a:endParaRPr>
+          </a:p>
+        </p:txBody>
+      </p:sp>
+      <p:sp>
+        <p:nvSpPr>
+          <p:cNvPr id="31" name="矩形: 圆角 30">
+            <a:extLst>
+              <a:ext uri="{FF2B5EF4-FFF2-40B4-BE49-F238E27FC236}">
+                <a16:creationId xmlns:a16="http://schemas.microsoft.com/office/drawing/2014/main" id="{1C06BD46-DC75-E3E6-F4D0-50044F76708F}"/>
+              </a:ext>
+            </a:extLst>
+          </p:cNvPr>
+          <p:cNvSpPr/>
+          <p:nvPr/>
+        </p:nvSpPr>
+        <p:spPr>
+          <a:xfrm>
+            <a:off x="8727511" y="3792143"/>
+            <a:ext cx="694445" cy="1120685"/>
+          </a:xfrm>
+          <a:prstGeom prst="roundRect">
+            <a:avLst>
+              <a:gd name="adj" fmla="val 9697"/>
+            </a:avLst>
+          </a:prstGeom>
+          <a:solidFill>
+            <a:schemeClr val="accent4">
+              <a:lumMod val="75000"/>
+              <a:alpha val="30196"/>
+            </a:schemeClr>
+          </a:solidFill>
+          <a:ln>
+            <a:noFill/>
+          </a:ln>
+        </p:spPr>
+        <p:style>
+          <a:lnRef idx="2">
+            <a:schemeClr val="accent1">
+              <a:shade val="50000"/>
+            </a:schemeClr>
+          </a:lnRef>
+          <a:fillRef idx="1">
+            <a:schemeClr val="accent1"/>
+          </a:fillRef>
+          <a:effectRef idx="0">
+            <a:schemeClr val="accent1"/>
+          </a:effectRef>
+          <a:fontRef idx="minor">
+            <a:schemeClr val="lt1"/>
+          </a:fontRef>
+        </p:style>
+        <p:txBody>
+          <a:bodyPr lIns="0" rIns="0" rtlCol="0" anchor="b"/>
+          <a:lstStyle/>
+          <a:p>
+            <a:pPr algn="ctr">
+              <a:lnSpc>
+                <a:spcPct val="80000"/>
+              </a:lnSpc>
+            </a:pPr>
+            <a:r>
+              <a:rPr lang="en-US" altLang="zh-CN" sz="1100" b="1" dirty="0">
+                <a:solidFill>
+                  <a:srgbClr val="0083E6"/>
+                </a:solidFill>
+              </a:rPr>
+              <a:t>96</a:t>
+            </a:r>
+            <a:r>
+              <a:rPr lang="en-US" altLang="zh-CN" sz="1100" b="1" dirty="0">
+                <a:solidFill>
+                  <a:srgbClr val="BF9000"/>
+                </a:solidFill>
+              </a:rPr>
+              <a:t>/</a:t>
+            </a:r>
+            <a:r>
+              <a:rPr lang="en-US" altLang="zh-CN" sz="1100" b="1" dirty="0">
+                <a:solidFill>
+                  <a:schemeClr val="bg1"/>
+                </a:solidFill>
+                <a:highlight>
+                  <a:srgbClr val="808080"/>
+                </a:highlight>
+              </a:rPr>
+              <a:t>64</a:t>
+            </a:r>
+            <a:br>
+              <a:rPr lang="en-US" altLang="zh-CN" sz="1300" b="1" dirty="0">
+                <a:solidFill>
+                  <a:schemeClr val="accent4">
+                    <a:lumMod val="75000"/>
+                  </a:schemeClr>
+                </a:solidFill>
+              </a:rPr>
+            </a:br>
+            <a:r>
+              <a:rPr lang="en-US" altLang="zh-CN" sz="1300" b="1" dirty="0">
+                <a:solidFill>
+                  <a:schemeClr val="accent4">
+                    <a:lumMod val="75000"/>
+                  </a:schemeClr>
+                </a:solidFill>
+              </a:rPr>
+              <a:t>ppr</a:t>
+            </a:r>
+            <a:endParaRPr lang="zh-CN" altLang="en-US" sz="1300" b="1" dirty="0">
+              <a:solidFill>
+                <a:schemeClr val="accent4">
+                  <a:lumMod val="75000"/>
+                </a:schemeClr>
+              </a:solidFill>
+            </a:endParaRPr>
+          </a:p>
+        </p:txBody>
+      </p:sp>
+      <p:sp>
+        <p:nvSpPr>
+          <p:cNvPr id="35" name="矩形: 圆角 34">
+            <a:extLst>
+              <a:ext uri="{FF2B5EF4-FFF2-40B4-BE49-F238E27FC236}">
+                <a16:creationId xmlns:a16="http://schemas.microsoft.com/office/drawing/2014/main" id="{9F5C55F4-9AB5-0381-5956-34BA2A087F74}"/>
+              </a:ext>
+            </a:extLst>
+          </p:cNvPr>
+          <p:cNvSpPr/>
+          <p:nvPr/>
+        </p:nvSpPr>
+        <p:spPr>
+          <a:xfrm>
+            <a:off x="9734637" y="3792143"/>
+            <a:ext cx="694445" cy="1120685"/>
+          </a:xfrm>
+          <a:prstGeom prst="roundRect">
+            <a:avLst>
+              <a:gd name="adj" fmla="val 9697"/>
+            </a:avLst>
+          </a:prstGeom>
+          <a:solidFill>
+            <a:schemeClr val="accent4">
+              <a:lumMod val="75000"/>
+              <a:alpha val="30196"/>
+            </a:schemeClr>
+          </a:solidFill>
+          <a:ln>
+            <a:noFill/>
+          </a:ln>
+        </p:spPr>
+        <p:style>
+          <a:lnRef idx="2">
+            <a:schemeClr val="accent1">
+              <a:shade val="50000"/>
+            </a:schemeClr>
+          </a:lnRef>
+          <a:fillRef idx="1">
+            <a:schemeClr val="accent1"/>
+          </a:fillRef>
+          <a:effectRef idx="0">
+            <a:schemeClr val="accent1"/>
+          </a:effectRef>
+          <a:fontRef idx="minor">
+            <a:schemeClr val="lt1"/>
+          </a:fontRef>
+        </p:style>
+        <p:txBody>
+          <a:bodyPr lIns="0" rIns="0" rtlCol="0" anchor="b"/>
+          <a:lstStyle/>
+          <a:p>
+            <a:pPr algn="ctr">
+              <a:lnSpc>
+                <a:spcPct val="80000"/>
+              </a:lnSpc>
+            </a:pPr>
+            <a:r>
+              <a:rPr lang="en-US" altLang="zh-CN" sz="1100" b="1" dirty="0">
+                <a:solidFill>
+                  <a:srgbClr val="0083E6"/>
+                </a:solidFill>
+              </a:rPr>
+              <a:t>48</a:t>
+            </a:r>
+            <a:r>
+              <a:rPr lang="en-US" altLang="zh-CN" sz="1100" b="1" dirty="0">
+                <a:solidFill>
+                  <a:srgbClr val="BF9000"/>
+                </a:solidFill>
+              </a:rPr>
+              <a:t>/</a:t>
+            </a:r>
+            <a:r>
+              <a:rPr lang="en-US" altLang="zh-CN" sz="1100" b="1" dirty="0">
+                <a:solidFill>
+                  <a:schemeClr val="bg1"/>
+                </a:solidFill>
+                <a:highlight>
+                  <a:srgbClr val="808080"/>
+                </a:highlight>
+              </a:rPr>
+              <a:t>32</a:t>
+            </a:r>
+            <a:br>
+              <a:rPr lang="en-US" altLang="zh-CN" sz="1300" b="1" dirty="0">
+                <a:solidFill>
+                  <a:schemeClr val="accent4">
+                    <a:lumMod val="75000"/>
+                  </a:schemeClr>
+                </a:solidFill>
+              </a:rPr>
+            </a:br>
+            <a:r>
+              <a:rPr lang="en-US" altLang="zh-CN" sz="1300" b="1" dirty="0">
+                <a:solidFill>
+                  <a:schemeClr val="accent4">
+                    <a:lumMod val="75000"/>
+                  </a:schemeClr>
+                </a:solidFill>
+              </a:rPr>
+              <a:t>ppr</a:t>
+            </a:r>
+            <a:endParaRPr lang="zh-CN" altLang="en-US" sz="1300" b="1" dirty="0">
+              <a:solidFill>
+                <a:schemeClr val="accent4">
+                  <a:lumMod val="75000"/>
                 </a:schemeClr>
               </a:solidFill>
             </a:endParaRPr>
@@ -24119,27 +24119,27 @@
             <a:r>
               <a:rPr lang="en-US" altLang="zh-CN" sz="1100" b="1" dirty="0">
                 <a:solidFill>
+                  <a:srgbClr val="0083E6"/>
+                </a:solidFill>
+              </a:rPr>
+              <a:t>256</a:t>
+            </a:r>
+            <a:r>
+              <a:rPr lang="en-US" altLang="zh-CN" sz="1100" b="1" spc="100" dirty="0">
+                <a:solidFill>
+                  <a:srgbClr val="BF9000"/>
+                </a:solidFill>
+              </a:rPr>
+              <a:t>/</a:t>
+            </a:r>
+            <a:r>
+              <a:rPr lang="en-US" altLang="zh-CN" sz="1100" b="1" dirty="0">
+                <a:solidFill>
                   <a:schemeClr val="bg1"/>
                 </a:solidFill>
                 <a:highlight>
                   <a:srgbClr val="808080"/>
                 </a:highlight>
-              </a:rPr>
-              <a:t>256</a:t>
-            </a:r>
-            <a:r>
-              <a:rPr lang="en-US" altLang="zh-CN" sz="1100" b="1" spc="100" dirty="0">
-                <a:solidFill>
-                  <a:srgbClr val="BF9000"/>
-                </a:solidFill>
-              </a:rPr>
-              <a:t>/</a:t>
-            </a:r>
-            <a:r>
-              <a:rPr lang="en-US" altLang="zh-CN" sz="1100" b="1" dirty="0">
-                <a:solidFill>
-                  <a:srgbClr val="0083E6"/>
-                </a:solidFill>
               </a:rPr>
               <a:t>200</a:t>
             </a:r>
@@ -24232,27 +24232,27 @@
             <a:r>
               <a:rPr lang="en-US" altLang="zh-CN" sz="1100" b="1" dirty="0">
                 <a:solidFill>
+                  <a:srgbClr val="0083E6"/>
+                </a:solidFill>
+              </a:rPr>
+              <a:t>160</a:t>
+            </a:r>
+            <a:r>
+              <a:rPr lang="en-US" altLang="zh-CN" sz="1100" b="1" dirty="0">
+                <a:solidFill>
+                  <a:srgbClr val="BF9000"/>
+                </a:solidFill>
+              </a:rPr>
+              <a:t>/</a:t>
+            </a:r>
+            <a:r>
+              <a:rPr lang="en-US" altLang="zh-CN" sz="1100" b="1" dirty="0">
+                <a:solidFill>
                   <a:schemeClr val="bg1"/>
                 </a:solidFill>
                 <a:highlight>
                   <a:srgbClr val="808080"/>
                 </a:highlight>
-              </a:rPr>
-              <a:t>160</a:t>
-            </a:r>
-            <a:r>
-              <a:rPr lang="en-US" altLang="zh-CN" sz="1100" b="1" dirty="0">
-                <a:solidFill>
-                  <a:srgbClr val="BF9000"/>
-                </a:solidFill>
-              </a:rPr>
-              <a:t>/</a:t>
-            </a:r>
-            <a:r>
-              <a:rPr lang="en-US" altLang="zh-CN" sz="1100" b="1" dirty="0">
-                <a:solidFill>
-                  <a:srgbClr val="0083E6"/>
-                </a:solidFill>
               </a:rPr>
               <a:t>128</a:t>
             </a:r>
@@ -24345,27 +24345,27 @@
             <a:r>
               <a:rPr lang="en-US" altLang="zh-CN" sz="1100" b="1" dirty="0">
                 <a:solidFill>
+                  <a:srgbClr val="0083E6"/>
+                </a:solidFill>
+              </a:rPr>
+              <a:t>96</a:t>
+            </a:r>
+            <a:r>
+              <a:rPr lang="en-US" altLang="zh-CN" sz="1100" b="1" dirty="0">
+                <a:solidFill>
+                  <a:srgbClr val="BF9000"/>
+                </a:solidFill>
+              </a:rPr>
+              <a:t>/</a:t>
+            </a:r>
+            <a:r>
+              <a:rPr lang="en-US" altLang="zh-CN" sz="1100" b="1" dirty="0">
+                <a:solidFill>
                   <a:schemeClr val="bg1"/>
                 </a:solidFill>
                 <a:highlight>
                   <a:srgbClr val="808080"/>
                 </a:highlight>
-              </a:rPr>
-              <a:t>96</a:t>
-            </a:r>
-            <a:r>
-              <a:rPr lang="en-US" altLang="zh-CN" sz="1100" b="1" dirty="0">
-                <a:solidFill>
-                  <a:srgbClr val="BF9000"/>
-                </a:solidFill>
-              </a:rPr>
-              <a:t>/</a:t>
-            </a:r>
-            <a:r>
-              <a:rPr lang="en-US" altLang="zh-CN" sz="1100" b="1" dirty="0">
-                <a:solidFill>
-                  <a:srgbClr val="0083E6"/>
-                </a:solidFill>
               </a:rPr>
               <a:t>64</a:t>
             </a:r>
@@ -24458,27 +24458,27 @@
             <a:r>
               <a:rPr lang="en-US" altLang="zh-CN" sz="1100" b="1" dirty="0">
                 <a:solidFill>
+                  <a:srgbClr val="0083E6"/>
+                </a:solidFill>
+              </a:rPr>
+              <a:t>48</a:t>
+            </a:r>
+            <a:r>
+              <a:rPr lang="en-US" altLang="zh-CN" sz="1100" b="1" dirty="0">
+                <a:solidFill>
+                  <a:srgbClr val="BF9000"/>
+                </a:solidFill>
+              </a:rPr>
+              <a:t>/</a:t>
+            </a:r>
+            <a:r>
+              <a:rPr lang="en-US" altLang="zh-CN" sz="1100" b="1" dirty="0">
+                <a:solidFill>
                   <a:schemeClr val="bg1"/>
                 </a:solidFill>
                 <a:highlight>
                   <a:srgbClr val="808080"/>
                 </a:highlight>
-              </a:rPr>
-              <a:t>48</a:t>
-            </a:r>
-            <a:r>
-              <a:rPr lang="en-US" altLang="zh-CN" sz="1100" b="1" dirty="0">
-                <a:solidFill>
-                  <a:srgbClr val="BF9000"/>
-                </a:solidFill>
-              </a:rPr>
-              <a:t>/</a:t>
-            </a:r>
-            <a:r>
-              <a:rPr lang="en-US" altLang="zh-CN" sz="1100" b="1" dirty="0">
-                <a:solidFill>
-                  <a:srgbClr val="0083E6"/>
-                </a:solidFill>
               </a:rPr>
               <a:t>32</a:t>
             </a:r>

</xml_diff>

<commit_message>
Config versioning and factory reset at power-up
</commit_message>
<xml_diff>
--- a/doc/IIDX_Pico_Manual.pptx
+++ b/doc/IIDX_Pico_Manual.pptx
@@ -1,6 +1,6 @@
 
 <file path=ppt/presentation.xml><?xml version="1.0" encoding="utf-8"?>
-<p:presentation xmlns:a="http://schemas.openxmlformats.org/drawingml/2006/main" xmlns:r="http://schemas.openxmlformats.org/officeDocument/2006/relationships" xmlns:p="http://schemas.openxmlformats.org/presentationml/2006/main" saveSubsetFonts="1">
+<p:presentation xmlns:a="http://schemas.openxmlformats.org/drawingml/2006/main" xmlns:r="http://schemas.openxmlformats.org/officeDocument/2006/relationships" xmlns:p="http://schemas.openxmlformats.org/presentationml/2006/main" saveSubsetFonts="1" autoCompressPictures="0">
   <p:sldMasterIdLst>
     <p:sldMasterId id="2147483650" r:id="rId1"/>
     <p:sldMasterId id="2147483648" r:id="rId2"/>
@@ -237,7 +237,7 @@
           <a:p>
             <a:fld id="{99D69C7F-8110-406B-A63E-81EB2EBDFE06}" type="datetimeFigureOut">
               <a:rPr lang="zh-CN" altLang="en-US" smtClean="0"/>
-              <a:t>2026/4/11</a:t>
+              <a:t>2026/4/19</a:t>
             </a:fld>
             <a:endParaRPr lang="zh-CN" altLang="en-US"/>
           </a:p>
@@ -415,7 +415,7 @@
           <a:p>
             <a:fld id="{002F3B7A-C25F-4CE1-8FEE-39C6D6ACD16A}" type="datetimeFigureOut">
               <a:rPr lang="zh-CN" altLang="en-US" smtClean="0"/>
-              <a:t>2026/4/11</a:t>
+              <a:t>2026/4/19</a:t>
             </a:fld>
             <a:endParaRPr lang="zh-CN" altLang="en-US"/>
           </a:p>
@@ -2203,7 +2203,7 @@
           <a:p>
             <a:r>
               <a:rPr lang="zh-CN" altLang="en-US" dirty="0"/>
-              <a:t>上电</a:t>
+              <a:t>上电时</a:t>
             </a:r>
           </a:p>
         </p:txBody>
@@ -2728,6 +2728,529 @@
           </a:p>
         </p:txBody>
       </p:sp>
+      <p:grpSp>
+        <p:nvGrpSpPr>
+          <p:cNvPr id="2" name="组合 1">
+            <a:extLst>
+              <a:ext uri="{FF2B5EF4-FFF2-40B4-BE49-F238E27FC236}">
+                <a16:creationId xmlns:a16="http://schemas.microsoft.com/office/drawing/2014/main" id="{1329A7A0-E3DD-6CAD-3019-3D28F9769E77}"/>
+              </a:ext>
+            </a:extLst>
+          </p:cNvPr>
+          <p:cNvGrpSpPr/>
+          <p:nvPr/>
+        </p:nvGrpSpPr>
+        <p:grpSpPr>
+          <a:xfrm>
+            <a:off x="5233987" y="752816"/>
+            <a:ext cx="4426659" cy="1163324"/>
+            <a:chOff x="5233987" y="752816"/>
+            <a:chExt cx="4426659" cy="1163324"/>
+          </a:xfrm>
+        </p:grpSpPr>
+        <p:cxnSp>
+          <p:nvCxnSpPr>
+            <p:cNvPr id="5" name="连接符: 肘形 4">
+              <a:extLst>
+                <a:ext uri="{FF2B5EF4-FFF2-40B4-BE49-F238E27FC236}">
+                  <a16:creationId xmlns:a16="http://schemas.microsoft.com/office/drawing/2014/main" id="{BC152FE3-A9E1-E435-6670-07462403335A}"/>
+                </a:ext>
+              </a:extLst>
+            </p:cNvPr>
+            <p:cNvCxnSpPr>
+              <a:cxnSpLocks/>
+              <a:stCxn id="11" idx="3"/>
+              <a:endCxn id="10" idx="0"/>
+            </p:cNvCxnSpPr>
+            <p:nvPr/>
+          </p:nvCxnSpPr>
+          <p:spPr>
+            <a:xfrm>
+              <a:off x="6172500" y="1020000"/>
+              <a:ext cx="3235561" cy="351191"/>
+            </a:xfrm>
+            <a:prstGeom prst="bentConnector2">
+              <a:avLst/>
+            </a:prstGeom>
+            <a:ln w="28575">
+              <a:solidFill>
+                <a:schemeClr val="accent2">
+                  <a:lumMod val="75000"/>
+                </a:schemeClr>
+              </a:solidFill>
+              <a:prstDash val="sysDot"/>
+            </a:ln>
+          </p:spPr>
+          <p:style>
+            <a:lnRef idx="1">
+              <a:schemeClr val="accent1"/>
+            </a:lnRef>
+            <a:fillRef idx="0">
+              <a:schemeClr val="accent1"/>
+            </a:fillRef>
+            <a:effectRef idx="0">
+              <a:schemeClr val="accent1"/>
+            </a:effectRef>
+            <a:fontRef idx="minor">
+              <a:schemeClr val="tx1"/>
+            </a:fontRef>
+          </p:style>
+        </p:cxnSp>
+        <p:sp>
+          <p:nvSpPr>
+            <p:cNvPr id="6" name="矩形: 圆角 5">
+              <a:extLst>
+                <a:ext uri="{FF2B5EF4-FFF2-40B4-BE49-F238E27FC236}">
+                  <a16:creationId xmlns:a16="http://schemas.microsoft.com/office/drawing/2014/main" id="{C6C5ED9A-15FF-1F2B-4C83-E0F74BA1E42B}"/>
+                </a:ext>
+              </a:extLst>
+            </p:cNvPr>
+            <p:cNvSpPr/>
+            <p:nvPr/>
+          </p:nvSpPr>
+          <p:spPr>
+            <a:xfrm>
+              <a:off x="6705666" y="1371191"/>
+              <a:ext cx="505170" cy="544949"/>
+            </a:xfrm>
+            <a:prstGeom prst="roundRect">
+              <a:avLst>
+                <a:gd name="adj" fmla="val 9697"/>
+              </a:avLst>
+            </a:prstGeom>
+            <a:solidFill>
+              <a:schemeClr val="accent2">
+                <a:lumMod val="40000"/>
+                <a:lumOff val="60000"/>
+                <a:alpha val="30196"/>
+              </a:schemeClr>
+            </a:solidFill>
+            <a:ln>
+              <a:noFill/>
+            </a:ln>
+          </p:spPr>
+          <p:style>
+            <a:lnRef idx="2">
+              <a:schemeClr val="accent1">
+                <a:shade val="50000"/>
+              </a:schemeClr>
+            </a:lnRef>
+            <a:fillRef idx="1">
+              <a:schemeClr val="accent1"/>
+            </a:fillRef>
+            <a:effectRef idx="0">
+              <a:schemeClr val="accent1"/>
+            </a:effectRef>
+            <a:fontRef idx="minor">
+              <a:schemeClr val="lt1"/>
+            </a:fontRef>
+          </p:style>
+          <p:txBody>
+            <a:bodyPr lIns="36000" tIns="36000" rIns="36000" bIns="36000" rtlCol="0" anchor="b"/>
+            <a:lstStyle/>
+            <a:p>
+              <a:pPr algn="ctr"/>
+              <a:endParaRPr lang="zh-CN" altLang="en-US" sz="800" b="1" dirty="0">
+                <a:solidFill>
+                  <a:srgbClr val="00B0F0"/>
+                </a:solidFill>
+              </a:endParaRPr>
+            </a:p>
+          </p:txBody>
+        </p:sp>
+        <p:sp>
+          <p:nvSpPr>
+            <p:cNvPr id="8" name="矩形: 圆角 7">
+              <a:extLst>
+                <a:ext uri="{FF2B5EF4-FFF2-40B4-BE49-F238E27FC236}">
+                  <a16:creationId xmlns:a16="http://schemas.microsoft.com/office/drawing/2014/main" id="{417909C3-CA2C-5073-91A4-9A37C347C4E4}"/>
+                </a:ext>
+              </a:extLst>
+            </p:cNvPr>
+            <p:cNvSpPr/>
+            <p:nvPr/>
+          </p:nvSpPr>
+          <p:spPr>
+            <a:xfrm>
+              <a:off x="7522269" y="1371191"/>
+              <a:ext cx="505170" cy="544949"/>
+            </a:xfrm>
+            <a:prstGeom prst="roundRect">
+              <a:avLst>
+                <a:gd name="adj" fmla="val 9697"/>
+              </a:avLst>
+            </a:prstGeom>
+            <a:solidFill>
+              <a:schemeClr val="accent2">
+                <a:lumMod val="40000"/>
+                <a:lumOff val="60000"/>
+                <a:alpha val="30196"/>
+              </a:schemeClr>
+            </a:solidFill>
+            <a:ln>
+              <a:noFill/>
+            </a:ln>
+          </p:spPr>
+          <p:style>
+            <a:lnRef idx="2">
+              <a:schemeClr val="accent1">
+                <a:shade val="50000"/>
+              </a:schemeClr>
+            </a:lnRef>
+            <a:fillRef idx="1">
+              <a:schemeClr val="accent1"/>
+            </a:fillRef>
+            <a:effectRef idx="0">
+              <a:schemeClr val="accent1"/>
+            </a:effectRef>
+            <a:fontRef idx="minor">
+              <a:schemeClr val="lt1"/>
+            </a:fontRef>
+          </p:style>
+          <p:txBody>
+            <a:bodyPr lIns="36000" tIns="36000" rIns="36000" bIns="36000" rtlCol="0" anchor="b"/>
+            <a:lstStyle/>
+            <a:p>
+              <a:pPr algn="ctr"/>
+              <a:endParaRPr lang="zh-CN" altLang="en-US" sz="800" b="1" dirty="0">
+                <a:solidFill>
+                  <a:srgbClr val="00B0F0"/>
+                </a:solidFill>
+              </a:endParaRPr>
+            </a:p>
+          </p:txBody>
+        </p:sp>
+        <p:sp>
+          <p:nvSpPr>
+            <p:cNvPr id="9" name="矩形: 圆角 8">
+              <a:extLst>
+                <a:ext uri="{FF2B5EF4-FFF2-40B4-BE49-F238E27FC236}">
+                  <a16:creationId xmlns:a16="http://schemas.microsoft.com/office/drawing/2014/main" id="{09CF2ECE-3801-02C3-1846-CEF39328E043}"/>
+                </a:ext>
+              </a:extLst>
+            </p:cNvPr>
+            <p:cNvSpPr/>
+            <p:nvPr/>
+          </p:nvSpPr>
+          <p:spPr>
+            <a:xfrm>
+              <a:off x="8338872" y="1371191"/>
+              <a:ext cx="505170" cy="544949"/>
+            </a:xfrm>
+            <a:prstGeom prst="roundRect">
+              <a:avLst>
+                <a:gd name="adj" fmla="val 9697"/>
+              </a:avLst>
+            </a:prstGeom>
+            <a:solidFill>
+              <a:schemeClr val="accent2">
+                <a:lumMod val="40000"/>
+                <a:lumOff val="60000"/>
+                <a:alpha val="30196"/>
+              </a:schemeClr>
+            </a:solidFill>
+            <a:ln>
+              <a:noFill/>
+            </a:ln>
+          </p:spPr>
+          <p:style>
+            <a:lnRef idx="2">
+              <a:schemeClr val="accent1">
+                <a:shade val="50000"/>
+              </a:schemeClr>
+            </a:lnRef>
+            <a:fillRef idx="1">
+              <a:schemeClr val="accent1"/>
+            </a:fillRef>
+            <a:effectRef idx="0">
+              <a:schemeClr val="accent1"/>
+            </a:effectRef>
+            <a:fontRef idx="minor">
+              <a:schemeClr val="lt1"/>
+            </a:fontRef>
+          </p:style>
+          <p:txBody>
+            <a:bodyPr lIns="36000" tIns="36000" rIns="36000" bIns="36000" rtlCol="0" anchor="b"/>
+            <a:lstStyle/>
+            <a:p>
+              <a:pPr algn="ctr"/>
+              <a:endParaRPr lang="zh-CN" altLang="en-US" sz="800" b="1" dirty="0">
+                <a:solidFill>
+                  <a:srgbClr val="00B0F0"/>
+                </a:solidFill>
+              </a:endParaRPr>
+            </a:p>
+          </p:txBody>
+        </p:sp>
+        <p:sp>
+          <p:nvSpPr>
+            <p:cNvPr id="10" name="矩形: 圆角 9">
+              <a:extLst>
+                <a:ext uri="{FF2B5EF4-FFF2-40B4-BE49-F238E27FC236}">
+                  <a16:creationId xmlns:a16="http://schemas.microsoft.com/office/drawing/2014/main" id="{A0A2EECE-A82C-0EC9-8825-66B0DD4967E1}"/>
+                </a:ext>
+              </a:extLst>
+            </p:cNvPr>
+            <p:cNvSpPr/>
+            <p:nvPr/>
+          </p:nvSpPr>
+          <p:spPr>
+            <a:xfrm>
+              <a:off x="9155476" y="1371191"/>
+              <a:ext cx="505170" cy="544949"/>
+            </a:xfrm>
+            <a:prstGeom prst="roundRect">
+              <a:avLst>
+                <a:gd name="adj" fmla="val 9697"/>
+              </a:avLst>
+            </a:prstGeom>
+            <a:solidFill>
+              <a:schemeClr val="accent2">
+                <a:lumMod val="40000"/>
+                <a:lumOff val="60000"/>
+                <a:alpha val="30196"/>
+              </a:schemeClr>
+            </a:solidFill>
+            <a:ln>
+              <a:noFill/>
+            </a:ln>
+          </p:spPr>
+          <p:style>
+            <a:lnRef idx="2">
+              <a:schemeClr val="accent1">
+                <a:shade val="50000"/>
+              </a:schemeClr>
+            </a:lnRef>
+            <a:fillRef idx="1">
+              <a:schemeClr val="accent1"/>
+            </a:fillRef>
+            <a:effectRef idx="0">
+              <a:schemeClr val="accent1"/>
+            </a:effectRef>
+            <a:fontRef idx="minor">
+              <a:schemeClr val="lt1"/>
+            </a:fontRef>
+          </p:style>
+          <p:txBody>
+            <a:bodyPr lIns="36000" tIns="36000" rIns="36000" bIns="36000" rtlCol="0" anchor="b"/>
+            <a:lstStyle/>
+            <a:p>
+              <a:pPr algn="ctr"/>
+              <a:endParaRPr lang="zh-CN" altLang="en-US" sz="800" b="1" dirty="0">
+                <a:solidFill>
+                  <a:srgbClr val="00B0F0"/>
+                </a:solidFill>
+              </a:endParaRPr>
+            </a:p>
+          </p:txBody>
+        </p:sp>
+        <p:sp>
+          <p:nvSpPr>
+            <p:cNvPr id="11" name="文本框 10">
+              <a:extLst>
+                <a:ext uri="{FF2B5EF4-FFF2-40B4-BE49-F238E27FC236}">
+                  <a16:creationId xmlns:a16="http://schemas.microsoft.com/office/drawing/2014/main" id="{DF71A08B-DF5B-176C-FE9F-29AC7018215A}"/>
+                </a:ext>
+              </a:extLst>
+            </p:cNvPr>
+            <p:cNvSpPr txBox="1"/>
+            <p:nvPr/>
+          </p:nvSpPr>
+          <p:spPr>
+            <a:xfrm>
+              <a:off x="5233987" y="752816"/>
+              <a:ext cx="938513" cy="534368"/>
+            </a:xfrm>
+            <a:prstGeom prst="rect">
+              <a:avLst/>
+            </a:prstGeom>
+            <a:noFill/>
+          </p:spPr>
+          <p:txBody>
+            <a:bodyPr wrap="square" lIns="36000" tIns="36000" rIns="36000" bIns="36000" rtlCol="0">
+              <a:spAutoFit/>
+            </a:bodyPr>
+            <a:lstStyle/>
+            <a:p>
+              <a:pPr algn="ctr">
+                <a:lnSpc>
+                  <a:spcPts val="1800"/>
+                </a:lnSpc>
+              </a:pPr>
+              <a:r>
+                <a:rPr lang="zh-CN" altLang="en-US" sz="1600" b="1" dirty="0">
+                  <a:solidFill>
+                    <a:schemeClr val="accent2">
+                      <a:lumMod val="75000"/>
+                    </a:schemeClr>
+                  </a:solidFill>
+                </a:rPr>
+                <a:t>恢复</a:t>
+              </a:r>
+              <a:br>
+                <a:rPr lang="en-US" altLang="zh-CN" sz="1600" b="1" dirty="0">
+                  <a:solidFill>
+                    <a:schemeClr val="accent2">
+                      <a:lumMod val="75000"/>
+                    </a:schemeClr>
+                  </a:solidFill>
+                </a:rPr>
+              </a:br>
+              <a:r>
+                <a:rPr lang="zh-CN" altLang="en-US" sz="1600" b="1" dirty="0">
+                  <a:solidFill>
+                    <a:schemeClr val="accent2">
+                      <a:lumMod val="75000"/>
+                    </a:schemeClr>
+                  </a:solidFill>
+                </a:rPr>
+                <a:t>出厂设置</a:t>
+              </a:r>
+            </a:p>
+          </p:txBody>
+        </p:sp>
+        <p:cxnSp>
+          <p:nvCxnSpPr>
+            <p:cNvPr id="12" name="直接连接符 11">
+              <a:extLst>
+                <a:ext uri="{FF2B5EF4-FFF2-40B4-BE49-F238E27FC236}">
+                  <a16:creationId xmlns:a16="http://schemas.microsoft.com/office/drawing/2014/main" id="{2058FFBD-50B8-E00E-E658-24FD68AA9B8D}"/>
+                </a:ext>
+              </a:extLst>
+            </p:cNvPr>
+            <p:cNvCxnSpPr>
+              <a:cxnSpLocks/>
+              <a:stCxn id="6" idx="0"/>
+            </p:cNvCxnSpPr>
+            <p:nvPr/>
+          </p:nvCxnSpPr>
+          <p:spPr>
+            <a:xfrm flipV="1">
+              <a:off x="6958251" y="1020000"/>
+              <a:ext cx="0" cy="351191"/>
+            </a:xfrm>
+            <a:prstGeom prst="line">
+              <a:avLst/>
+            </a:prstGeom>
+            <a:ln w="28575">
+              <a:solidFill>
+                <a:schemeClr val="accent2">
+                  <a:lumMod val="75000"/>
+                </a:schemeClr>
+              </a:solidFill>
+              <a:prstDash val="sysDot"/>
+            </a:ln>
+          </p:spPr>
+          <p:style>
+            <a:lnRef idx="1">
+              <a:schemeClr val="accent1"/>
+            </a:lnRef>
+            <a:fillRef idx="0">
+              <a:schemeClr val="accent1"/>
+            </a:fillRef>
+            <a:effectRef idx="0">
+              <a:schemeClr val="accent1"/>
+            </a:effectRef>
+            <a:fontRef idx="minor">
+              <a:schemeClr val="tx1"/>
+            </a:fontRef>
+          </p:style>
+        </p:cxnSp>
+        <p:cxnSp>
+          <p:nvCxnSpPr>
+            <p:cNvPr id="13" name="直接连接符 12">
+              <a:extLst>
+                <a:ext uri="{FF2B5EF4-FFF2-40B4-BE49-F238E27FC236}">
+                  <a16:creationId xmlns:a16="http://schemas.microsoft.com/office/drawing/2014/main" id="{AD8ACF6A-60CD-D64A-A9FA-1D8CA7336015}"/>
+                </a:ext>
+              </a:extLst>
+            </p:cNvPr>
+            <p:cNvCxnSpPr>
+              <a:cxnSpLocks/>
+              <a:stCxn id="8" idx="0"/>
+            </p:cNvCxnSpPr>
+            <p:nvPr/>
+          </p:nvCxnSpPr>
+          <p:spPr>
+            <a:xfrm flipV="1">
+              <a:off x="7774854" y="1020000"/>
+              <a:ext cx="0" cy="351191"/>
+            </a:xfrm>
+            <a:prstGeom prst="line">
+              <a:avLst/>
+            </a:prstGeom>
+            <a:ln w="28575">
+              <a:solidFill>
+                <a:schemeClr val="accent2">
+                  <a:lumMod val="75000"/>
+                </a:schemeClr>
+              </a:solidFill>
+              <a:prstDash val="sysDot"/>
+            </a:ln>
+          </p:spPr>
+          <p:style>
+            <a:lnRef idx="1">
+              <a:schemeClr val="accent1"/>
+            </a:lnRef>
+            <a:fillRef idx="0">
+              <a:schemeClr val="accent1"/>
+            </a:fillRef>
+            <a:effectRef idx="0">
+              <a:schemeClr val="accent1"/>
+            </a:effectRef>
+            <a:fontRef idx="minor">
+              <a:schemeClr val="tx1"/>
+            </a:fontRef>
+          </p:style>
+        </p:cxnSp>
+        <p:cxnSp>
+          <p:nvCxnSpPr>
+            <p:cNvPr id="14" name="直接连接符 13">
+              <a:extLst>
+                <a:ext uri="{FF2B5EF4-FFF2-40B4-BE49-F238E27FC236}">
+                  <a16:creationId xmlns:a16="http://schemas.microsoft.com/office/drawing/2014/main" id="{702EE474-CE39-CE95-89C0-4044D01A0753}"/>
+                </a:ext>
+              </a:extLst>
+            </p:cNvPr>
+            <p:cNvCxnSpPr>
+              <a:cxnSpLocks/>
+              <a:stCxn id="9" idx="0"/>
+            </p:cNvCxnSpPr>
+            <p:nvPr/>
+          </p:nvCxnSpPr>
+          <p:spPr>
+            <a:xfrm flipV="1">
+              <a:off x="8591457" y="1020000"/>
+              <a:ext cx="0" cy="351191"/>
+            </a:xfrm>
+            <a:prstGeom prst="line">
+              <a:avLst/>
+            </a:prstGeom>
+            <a:ln w="28575">
+              <a:solidFill>
+                <a:schemeClr val="accent2">
+                  <a:lumMod val="75000"/>
+                </a:schemeClr>
+              </a:solidFill>
+              <a:prstDash val="sysDot"/>
+            </a:ln>
+          </p:spPr>
+          <p:style>
+            <a:lnRef idx="1">
+              <a:schemeClr val="accent1"/>
+            </a:lnRef>
+            <a:fillRef idx="0">
+              <a:schemeClr val="accent1"/>
+            </a:fillRef>
+            <a:effectRef idx="0">
+              <a:schemeClr val="accent1"/>
+            </a:effectRef>
+            <a:fontRef idx="minor">
+              <a:schemeClr val="tx1"/>
+            </a:fontRef>
+          </p:style>
+        </p:cxnSp>
+      </p:grpSp>
     </p:spTree>
     <p:extLst>
       <p:ext uri="{BB962C8B-B14F-4D97-AF65-F5344CB8AC3E}">
@@ -10447,7 +10970,7 @@
           <a:p>
             <a:r>
               <a:rPr lang="ko-KR" altLang="en-US" dirty="0"/>
-              <a:t>전원 켜기</a:t>
+              <a:t>전원 인가 시</a:t>
             </a:r>
             <a:endParaRPr lang="zh-CN" altLang="en-US" dirty="0"/>
           </a:p>
@@ -11013,6 +11536,517 @@
           </a:p>
         </p:txBody>
       </p:sp>
+      <p:grpSp>
+        <p:nvGrpSpPr>
+          <p:cNvPr id="2" name="组合 1">
+            <a:extLst>
+              <a:ext uri="{FF2B5EF4-FFF2-40B4-BE49-F238E27FC236}">
+                <a16:creationId xmlns:a16="http://schemas.microsoft.com/office/drawing/2014/main" id="{71D26332-437D-B256-3C4B-64B21CCB24BB}"/>
+              </a:ext>
+            </a:extLst>
+          </p:cNvPr>
+          <p:cNvGrpSpPr/>
+          <p:nvPr/>
+        </p:nvGrpSpPr>
+        <p:grpSpPr>
+          <a:xfrm>
+            <a:off x="5233988" y="796328"/>
+            <a:ext cx="4426658" cy="1119812"/>
+            <a:chOff x="5233988" y="796328"/>
+            <a:chExt cx="4426658" cy="1119812"/>
+          </a:xfrm>
+        </p:grpSpPr>
+        <p:cxnSp>
+          <p:nvCxnSpPr>
+            <p:cNvPr id="5" name="连接符: 肘形 4">
+              <a:extLst>
+                <a:ext uri="{FF2B5EF4-FFF2-40B4-BE49-F238E27FC236}">
+                  <a16:creationId xmlns:a16="http://schemas.microsoft.com/office/drawing/2014/main" id="{80A4716B-56F6-066B-AF32-3BD1D138589A}"/>
+                </a:ext>
+              </a:extLst>
+            </p:cNvPr>
+            <p:cNvCxnSpPr>
+              <a:cxnSpLocks/>
+              <a:stCxn id="11" idx="3"/>
+              <a:endCxn id="10" idx="0"/>
+            </p:cNvCxnSpPr>
+            <p:nvPr/>
+          </p:nvCxnSpPr>
+          <p:spPr>
+            <a:xfrm>
+              <a:off x="6172501" y="1063512"/>
+              <a:ext cx="3235560" cy="307679"/>
+            </a:xfrm>
+            <a:prstGeom prst="bentConnector2">
+              <a:avLst/>
+            </a:prstGeom>
+            <a:ln w="28575">
+              <a:solidFill>
+                <a:schemeClr val="accent2">
+                  <a:lumMod val="75000"/>
+                </a:schemeClr>
+              </a:solidFill>
+              <a:prstDash val="sysDot"/>
+            </a:ln>
+          </p:spPr>
+          <p:style>
+            <a:lnRef idx="1">
+              <a:schemeClr val="accent1"/>
+            </a:lnRef>
+            <a:fillRef idx="0">
+              <a:schemeClr val="accent1"/>
+            </a:fillRef>
+            <a:effectRef idx="0">
+              <a:schemeClr val="accent1"/>
+            </a:effectRef>
+            <a:fontRef idx="minor">
+              <a:schemeClr val="tx1"/>
+            </a:fontRef>
+          </p:style>
+        </p:cxnSp>
+        <p:sp>
+          <p:nvSpPr>
+            <p:cNvPr id="6" name="矩形: 圆角 5">
+              <a:extLst>
+                <a:ext uri="{FF2B5EF4-FFF2-40B4-BE49-F238E27FC236}">
+                  <a16:creationId xmlns:a16="http://schemas.microsoft.com/office/drawing/2014/main" id="{67C7B1A8-5AB3-2A6C-D28F-C271D3FD11C9}"/>
+                </a:ext>
+              </a:extLst>
+            </p:cNvPr>
+            <p:cNvSpPr/>
+            <p:nvPr/>
+          </p:nvSpPr>
+          <p:spPr>
+            <a:xfrm>
+              <a:off x="6705666" y="1371191"/>
+              <a:ext cx="505170" cy="544949"/>
+            </a:xfrm>
+            <a:prstGeom prst="roundRect">
+              <a:avLst>
+                <a:gd name="adj" fmla="val 9697"/>
+              </a:avLst>
+            </a:prstGeom>
+            <a:solidFill>
+              <a:schemeClr val="accent2">
+                <a:lumMod val="40000"/>
+                <a:lumOff val="60000"/>
+                <a:alpha val="30196"/>
+              </a:schemeClr>
+            </a:solidFill>
+            <a:ln>
+              <a:noFill/>
+            </a:ln>
+          </p:spPr>
+          <p:style>
+            <a:lnRef idx="2">
+              <a:schemeClr val="accent1">
+                <a:shade val="50000"/>
+              </a:schemeClr>
+            </a:lnRef>
+            <a:fillRef idx="1">
+              <a:schemeClr val="accent1"/>
+            </a:fillRef>
+            <a:effectRef idx="0">
+              <a:schemeClr val="accent1"/>
+            </a:effectRef>
+            <a:fontRef idx="minor">
+              <a:schemeClr val="lt1"/>
+            </a:fontRef>
+          </p:style>
+          <p:txBody>
+            <a:bodyPr lIns="36000" tIns="36000" rIns="36000" bIns="36000" rtlCol="0" anchor="b"/>
+            <a:lstStyle/>
+            <a:p>
+              <a:pPr algn="ctr"/>
+              <a:endParaRPr lang="zh-CN" altLang="en-US" sz="800" b="1" dirty="0">
+                <a:solidFill>
+                  <a:srgbClr val="00B0F0"/>
+                </a:solidFill>
+              </a:endParaRPr>
+            </a:p>
+          </p:txBody>
+        </p:sp>
+        <p:sp>
+          <p:nvSpPr>
+            <p:cNvPr id="8" name="矩形: 圆角 7">
+              <a:extLst>
+                <a:ext uri="{FF2B5EF4-FFF2-40B4-BE49-F238E27FC236}">
+                  <a16:creationId xmlns:a16="http://schemas.microsoft.com/office/drawing/2014/main" id="{1EDCF7FB-8B0A-1C0C-C9B8-7D4653DB08C5}"/>
+                </a:ext>
+              </a:extLst>
+            </p:cNvPr>
+            <p:cNvSpPr/>
+            <p:nvPr/>
+          </p:nvSpPr>
+          <p:spPr>
+            <a:xfrm>
+              <a:off x="7522269" y="1371191"/>
+              <a:ext cx="505170" cy="544949"/>
+            </a:xfrm>
+            <a:prstGeom prst="roundRect">
+              <a:avLst>
+                <a:gd name="adj" fmla="val 9697"/>
+              </a:avLst>
+            </a:prstGeom>
+            <a:solidFill>
+              <a:schemeClr val="accent2">
+                <a:lumMod val="40000"/>
+                <a:lumOff val="60000"/>
+                <a:alpha val="30196"/>
+              </a:schemeClr>
+            </a:solidFill>
+            <a:ln>
+              <a:noFill/>
+            </a:ln>
+          </p:spPr>
+          <p:style>
+            <a:lnRef idx="2">
+              <a:schemeClr val="accent1">
+                <a:shade val="50000"/>
+              </a:schemeClr>
+            </a:lnRef>
+            <a:fillRef idx="1">
+              <a:schemeClr val="accent1"/>
+            </a:fillRef>
+            <a:effectRef idx="0">
+              <a:schemeClr val="accent1"/>
+            </a:effectRef>
+            <a:fontRef idx="minor">
+              <a:schemeClr val="lt1"/>
+            </a:fontRef>
+          </p:style>
+          <p:txBody>
+            <a:bodyPr lIns="36000" tIns="36000" rIns="36000" bIns="36000" rtlCol="0" anchor="b"/>
+            <a:lstStyle/>
+            <a:p>
+              <a:pPr algn="ctr"/>
+              <a:endParaRPr lang="zh-CN" altLang="en-US" sz="800" b="1" dirty="0">
+                <a:solidFill>
+                  <a:srgbClr val="00B0F0"/>
+                </a:solidFill>
+              </a:endParaRPr>
+            </a:p>
+          </p:txBody>
+        </p:sp>
+        <p:sp>
+          <p:nvSpPr>
+            <p:cNvPr id="9" name="矩形: 圆角 8">
+              <a:extLst>
+                <a:ext uri="{FF2B5EF4-FFF2-40B4-BE49-F238E27FC236}">
+                  <a16:creationId xmlns:a16="http://schemas.microsoft.com/office/drawing/2014/main" id="{F941A0EE-F051-E889-A2F1-247BBA923671}"/>
+                </a:ext>
+              </a:extLst>
+            </p:cNvPr>
+            <p:cNvSpPr/>
+            <p:nvPr/>
+          </p:nvSpPr>
+          <p:spPr>
+            <a:xfrm>
+              <a:off x="8338872" y="1371191"/>
+              <a:ext cx="505170" cy="544949"/>
+            </a:xfrm>
+            <a:prstGeom prst="roundRect">
+              <a:avLst>
+                <a:gd name="adj" fmla="val 9697"/>
+              </a:avLst>
+            </a:prstGeom>
+            <a:solidFill>
+              <a:schemeClr val="accent2">
+                <a:lumMod val="40000"/>
+                <a:lumOff val="60000"/>
+                <a:alpha val="30196"/>
+              </a:schemeClr>
+            </a:solidFill>
+            <a:ln>
+              <a:noFill/>
+            </a:ln>
+          </p:spPr>
+          <p:style>
+            <a:lnRef idx="2">
+              <a:schemeClr val="accent1">
+                <a:shade val="50000"/>
+              </a:schemeClr>
+            </a:lnRef>
+            <a:fillRef idx="1">
+              <a:schemeClr val="accent1"/>
+            </a:fillRef>
+            <a:effectRef idx="0">
+              <a:schemeClr val="accent1"/>
+            </a:effectRef>
+            <a:fontRef idx="minor">
+              <a:schemeClr val="lt1"/>
+            </a:fontRef>
+          </p:style>
+          <p:txBody>
+            <a:bodyPr lIns="36000" tIns="36000" rIns="36000" bIns="36000" rtlCol="0" anchor="b"/>
+            <a:lstStyle/>
+            <a:p>
+              <a:pPr algn="ctr"/>
+              <a:endParaRPr lang="zh-CN" altLang="en-US" sz="800" b="1" dirty="0">
+                <a:solidFill>
+                  <a:srgbClr val="00B0F0"/>
+                </a:solidFill>
+              </a:endParaRPr>
+            </a:p>
+          </p:txBody>
+        </p:sp>
+        <p:sp>
+          <p:nvSpPr>
+            <p:cNvPr id="10" name="矩形: 圆角 9">
+              <a:extLst>
+                <a:ext uri="{FF2B5EF4-FFF2-40B4-BE49-F238E27FC236}">
+                  <a16:creationId xmlns:a16="http://schemas.microsoft.com/office/drawing/2014/main" id="{5A6FAC20-BD7F-301F-8997-4038541FA40E}"/>
+                </a:ext>
+              </a:extLst>
+            </p:cNvPr>
+            <p:cNvSpPr/>
+            <p:nvPr/>
+          </p:nvSpPr>
+          <p:spPr>
+            <a:xfrm>
+              <a:off x="9155476" y="1371191"/>
+              <a:ext cx="505170" cy="544949"/>
+            </a:xfrm>
+            <a:prstGeom prst="roundRect">
+              <a:avLst>
+                <a:gd name="adj" fmla="val 9697"/>
+              </a:avLst>
+            </a:prstGeom>
+            <a:solidFill>
+              <a:schemeClr val="accent2">
+                <a:lumMod val="40000"/>
+                <a:lumOff val="60000"/>
+                <a:alpha val="30196"/>
+              </a:schemeClr>
+            </a:solidFill>
+            <a:ln>
+              <a:noFill/>
+            </a:ln>
+          </p:spPr>
+          <p:style>
+            <a:lnRef idx="2">
+              <a:schemeClr val="accent1">
+                <a:shade val="50000"/>
+              </a:schemeClr>
+            </a:lnRef>
+            <a:fillRef idx="1">
+              <a:schemeClr val="accent1"/>
+            </a:fillRef>
+            <a:effectRef idx="0">
+              <a:schemeClr val="accent1"/>
+            </a:effectRef>
+            <a:fontRef idx="minor">
+              <a:schemeClr val="lt1"/>
+            </a:fontRef>
+          </p:style>
+          <p:txBody>
+            <a:bodyPr lIns="36000" tIns="36000" rIns="36000" bIns="36000" rtlCol="0" anchor="b"/>
+            <a:lstStyle/>
+            <a:p>
+              <a:pPr algn="ctr"/>
+              <a:endParaRPr lang="zh-CN" altLang="en-US" sz="800" b="1" dirty="0">
+                <a:solidFill>
+                  <a:srgbClr val="00B0F0"/>
+                </a:solidFill>
+              </a:endParaRPr>
+            </a:p>
+          </p:txBody>
+        </p:sp>
+        <p:sp>
+          <p:nvSpPr>
+            <p:cNvPr id="11" name="文本框 10">
+              <a:extLst>
+                <a:ext uri="{FF2B5EF4-FFF2-40B4-BE49-F238E27FC236}">
+                  <a16:creationId xmlns:a16="http://schemas.microsoft.com/office/drawing/2014/main" id="{393EBCBC-7CAC-3BA0-FDF8-3B07003503A1}"/>
+                </a:ext>
+              </a:extLst>
+            </p:cNvPr>
+            <p:cNvSpPr txBox="1"/>
+            <p:nvPr/>
+          </p:nvSpPr>
+          <p:spPr>
+            <a:xfrm>
+              <a:off x="5233988" y="796328"/>
+              <a:ext cx="938513" cy="534368"/>
+            </a:xfrm>
+            <a:prstGeom prst="rect">
+              <a:avLst/>
+            </a:prstGeom>
+            <a:noFill/>
+          </p:spPr>
+          <p:txBody>
+            <a:bodyPr wrap="square" lIns="36000" tIns="36000" rIns="36000" bIns="36000" rtlCol="0">
+              <a:spAutoFit/>
+            </a:bodyPr>
+            <a:lstStyle/>
+            <a:p>
+              <a:pPr algn="ctr">
+                <a:lnSpc>
+                  <a:spcPts val="1800"/>
+                </a:lnSpc>
+              </a:pPr>
+              <a:r>
+                <a:rPr lang="ko-KR" altLang="en-US" sz="1600" b="1" dirty="0">
+                  <a:solidFill>
+                    <a:schemeClr val="accent2">
+                      <a:lumMod val="75000"/>
+                    </a:schemeClr>
+                  </a:solidFill>
+                </a:rPr>
+                <a:t>공장 초기화</a:t>
+              </a:r>
+              <a:endParaRPr lang="zh-CN" altLang="en-US" sz="1600" b="1" dirty="0">
+                <a:solidFill>
+                  <a:schemeClr val="accent2">
+                    <a:lumMod val="75000"/>
+                  </a:schemeClr>
+                </a:solidFill>
+              </a:endParaRPr>
+            </a:p>
+          </p:txBody>
+        </p:sp>
+        <p:cxnSp>
+          <p:nvCxnSpPr>
+            <p:cNvPr id="12" name="直接连接符 11">
+              <a:extLst>
+                <a:ext uri="{FF2B5EF4-FFF2-40B4-BE49-F238E27FC236}">
+                  <a16:creationId xmlns:a16="http://schemas.microsoft.com/office/drawing/2014/main" id="{AE773737-C914-24AD-D854-4F794E2E2055}"/>
+                </a:ext>
+              </a:extLst>
+            </p:cNvPr>
+            <p:cNvCxnSpPr>
+              <a:cxnSpLocks/>
+              <a:stCxn id="6" idx="0"/>
+            </p:cNvCxnSpPr>
+            <p:nvPr/>
+          </p:nvCxnSpPr>
+          <p:spPr>
+            <a:xfrm flipH="1" flipV="1">
+              <a:off x="6954380" y="1063512"/>
+              <a:ext cx="3871" cy="307679"/>
+            </a:xfrm>
+            <a:prstGeom prst="line">
+              <a:avLst/>
+            </a:prstGeom>
+            <a:ln w="28575">
+              <a:solidFill>
+                <a:schemeClr val="accent2">
+                  <a:lumMod val="75000"/>
+                </a:schemeClr>
+              </a:solidFill>
+              <a:prstDash val="sysDot"/>
+            </a:ln>
+          </p:spPr>
+          <p:style>
+            <a:lnRef idx="1">
+              <a:schemeClr val="accent1"/>
+            </a:lnRef>
+            <a:fillRef idx="0">
+              <a:schemeClr val="accent1"/>
+            </a:fillRef>
+            <a:effectRef idx="0">
+              <a:schemeClr val="accent1"/>
+            </a:effectRef>
+            <a:fontRef idx="minor">
+              <a:schemeClr val="tx1"/>
+            </a:fontRef>
+          </p:style>
+        </p:cxnSp>
+        <p:cxnSp>
+          <p:nvCxnSpPr>
+            <p:cNvPr id="13" name="直接连接符 12">
+              <a:extLst>
+                <a:ext uri="{FF2B5EF4-FFF2-40B4-BE49-F238E27FC236}">
+                  <a16:creationId xmlns:a16="http://schemas.microsoft.com/office/drawing/2014/main" id="{5D807A25-AFA1-B48E-FC11-07F4046E7F76}"/>
+                </a:ext>
+              </a:extLst>
+            </p:cNvPr>
+            <p:cNvCxnSpPr>
+              <a:cxnSpLocks/>
+              <a:stCxn id="8" idx="0"/>
+            </p:cNvCxnSpPr>
+            <p:nvPr/>
+          </p:nvCxnSpPr>
+          <p:spPr>
+            <a:xfrm flipH="1" flipV="1">
+              <a:off x="7770984" y="1063512"/>
+              <a:ext cx="3870" cy="307679"/>
+            </a:xfrm>
+            <a:prstGeom prst="line">
+              <a:avLst/>
+            </a:prstGeom>
+            <a:ln w="28575">
+              <a:solidFill>
+                <a:schemeClr val="accent2">
+                  <a:lumMod val="75000"/>
+                </a:schemeClr>
+              </a:solidFill>
+              <a:prstDash val="sysDot"/>
+            </a:ln>
+          </p:spPr>
+          <p:style>
+            <a:lnRef idx="1">
+              <a:schemeClr val="accent1"/>
+            </a:lnRef>
+            <a:fillRef idx="0">
+              <a:schemeClr val="accent1"/>
+            </a:fillRef>
+            <a:effectRef idx="0">
+              <a:schemeClr val="accent1"/>
+            </a:effectRef>
+            <a:fontRef idx="minor">
+              <a:schemeClr val="tx1"/>
+            </a:fontRef>
+          </p:style>
+        </p:cxnSp>
+        <p:cxnSp>
+          <p:nvCxnSpPr>
+            <p:cNvPr id="14" name="直接连接符 13">
+              <a:extLst>
+                <a:ext uri="{FF2B5EF4-FFF2-40B4-BE49-F238E27FC236}">
+                  <a16:creationId xmlns:a16="http://schemas.microsoft.com/office/drawing/2014/main" id="{80E62684-9A72-EA5F-22D9-161536EAA7B3}"/>
+                </a:ext>
+              </a:extLst>
+            </p:cNvPr>
+            <p:cNvCxnSpPr>
+              <a:cxnSpLocks/>
+              <a:stCxn id="9" idx="0"/>
+            </p:cNvCxnSpPr>
+            <p:nvPr/>
+          </p:nvCxnSpPr>
+          <p:spPr>
+            <a:xfrm flipH="1" flipV="1">
+              <a:off x="8588640" y="1063512"/>
+              <a:ext cx="2817" cy="307679"/>
+            </a:xfrm>
+            <a:prstGeom prst="line">
+              <a:avLst/>
+            </a:prstGeom>
+            <a:ln w="28575">
+              <a:solidFill>
+                <a:schemeClr val="accent2">
+                  <a:lumMod val="75000"/>
+                </a:schemeClr>
+              </a:solidFill>
+              <a:prstDash val="sysDot"/>
+            </a:ln>
+          </p:spPr>
+          <p:style>
+            <a:lnRef idx="1">
+              <a:schemeClr val="accent1"/>
+            </a:lnRef>
+            <a:fillRef idx="0">
+              <a:schemeClr val="accent1"/>
+            </a:fillRef>
+            <a:effectRef idx="0">
+              <a:schemeClr val="accent1"/>
+            </a:effectRef>
+            <a:fontRef idx="minor">
+              <a:schemeClr val="tx1"/>
+            </a:fontRef>
+          </p:style>
+        </p:cxnSp>
+      </p:grpSp>
     </p:spTree>
     <p:extLst>
       <p:ext uri="{BB962C8B-B14F-4D97-AF65-F5344CB8AC3E}">
@@ -12886,7 +13920,7 @@
           <a:p>
             <a:r>
               <a:rPr lang="en-US" altLang="zh-CN" dirty="0"/>
-              <a:t>POWER-ON</a:t>
+              <a:t>AT POWER-ON</a:t>
             </a:r>
             <a:endParaRPr lang="zh-CN" altLang="en-US" dirty="0"/>
           </a:p>
@@ -13447,6 +14481,517 @@
           </a:p>
         </p:txBody>
       </p:sp>
+      <p:grpSp>
+        <p:nvGrpSpPr>
+          <p:cNvPr id="49" name="组合 48">
+            <a:extLst>
+              <a:ext uri="{FF2B5EF4-FFF2-40B4-BE49-F238E27FC236}">
+                <a16:creationId xmlns:a16="http://schemas.microsoft.com/office/drawing/2014/main" id="{20D3315A-F1B7-FAF3-8E1B-DE1931D21C4F}"/>
+              </a:ext>
+            </a:extLst>
+          </p:cNvPr>
+          <p:cNvGrpSpPr/>
+          <p:nvPr/>
+        </p:nvGrpSpPr>
+        <p:grpSpPr>
+          <a:xfrm>
+            <a:off x="5242184" y="836823"/>
+            <a:ext cx="4418462" cy="1079317"/>
+            <a:chOff x="5242184" y="836823"/>
+            <a:chExt cx="4418462" cy="1079317"/>
+          </a:xfrm>
+        </p:grpSpPr>
+        <p:cxnSp>
+          <p:nvCxnSpPr>
+            <p:cNvPr id="2" name="连接符: 肘形 1">
+              <a:extLst>
+                <a:ext uri="{FF2B5EF4-FFF2-40B4-BE49-F238E27FC236}">
+                  <a16:creationId xmlns:a16="http://schemas.microsoft.com/office/drawing/2014/main" id="{B99E58E9-35DB-FC54-52FC-E6AD95CC6A62}"/>
+                </a:ext>
+              </a:extLst>
+            </p:cNvPr>
+            <p:cNvCxnSpPr>
+              <a:cxnSpLocks/>
+              <a:stCxn id="16" idx="3"/>
+              <a:endCxn id="12" idx="0"/>
+            </p:cNvCxnSpPr>
+            <p:nvPr/>
+          </p:nvCxnSpPr>
+          <p:spPr>
+            <a:xfrm>
+              <a:off x="6180697" y="1104007"/>
+              <a:ext cx="3227364" cy="267184"/>
+            </a:xfrm>
+            <a:prstGeom prst="bentConnector2">
+              <a:avLst/>
+            </a:prstGeom>
+            <a:ln w="28575">
+              <a:solidFill>
+                <a:schemeClr val="accent2">
+                  <a:lumMod val="75000"/>
+                </a:schemeClr>
+              </a:solidFill>
+              <a:prstDash val="sysDot"/>
+            </a:ln>
+          </p:spPr>
+          <p:style>
+            <a:lnRef idx="1">
+              <a:schemeClr val="accent1"/>
+            </a:lnRef>
+            <a:fillRef idx="0">
+              <a:schemeClr val="accent1"/>
+            </a:fillRef>
+            <a:effectRef idx="0">
+              <a:schemeClr val="accent1"/>
+            </a:effectRef>
+            <a:fontRef idx="minor">
+              <a:schemeClr val="tx1"/>
+            </a:fontRef>
+          </p:style>
+        </p:cxnSp>
+        <p:sp>
+          <p:nvSpPr>
+            <p:cNvPr id="9" name="矩形: 圆角 8">
+              <a:extLst>
+                <a:ext uri="{FF2B5EF4-FFF2-40B4-BE49-F238E27FC236}">
+                  <a16:creationId xmlns:a16="http://schemas.microsoft.com/office/drawing/2014/main" id="{BFFCE3A4-B415-0AD8-CF89-9A21B28774F6}"/>
+                </a:ext>
+              </a:extLst>
+            </p:cNvPr>
+            <p:cNvSpPr/>
+            <p:nvPr/>
+          </p:nvSpPr>
+          <p:spPr>
+            <a:xfrm>
+              <a:off x="6705666" y="1371191"/>
+              <a:ext cx="505170" cy="544949"/>
+            </a:xfrm>
+            <a:prstGeom prst="roundRect">
+              <a:avLst>
+                <a:gd name="adj" fmla="val 9697"/>
+              </a:avLst>
+            </a:prstGeom>
+            <a:solidFill>
+              <a:schemeClr val="accent2">
+                <a:lumMod val="40000"/>
+                <a:lumOff val="60000"/>
+                <a:alpha val="30196"/>
+              </a:schemeClr>
+            </a:solidFill>
+            <a:ln>
+              <a:noFill/>
+            </a:ln>
+          </p:spPr>
+          <p:style>
+            <a:lnRef idx="2">
+              <a:schemeClr val="accent1">
+                <a:shade val="50000"/>
+              </a:schemeClr>
+            </a:lnRef>
+            <a:fillRef idx="1">
+              <a:schemeClr val="accent1"/>
+            </a:fillRef>
+            <a:effectRef idx="0">
+              <a:schemeClr val="accent1"/>
+            </a:effectRef>
+            <a:fontRef idx="minor">
+              <a:schemeClr val="lt1"/>
+            </a:fontRef>
+          </p:style>
+          <p:txBody>
+            <a:bodyPr lIns="36000" tIns="36000" rIns="36000" bIns="36000" rtlCol="0" anchor="b"/>
+            <a:lstStyle/>
+            <a:p>
+              <a:pPr algn="ctr"/>
+              <a:endParaRPr lang="zh-CN" altLang="en-US" sz="800" b="1" dirty="0">
+                <a:solidFill>
+                  <a:srgbClr val="00B0F0"/>
+                </a:solidFill>
+              </a:endParaRPr>
+            </a:p>
+          </p:txBody>
+        </p:sp>
+        <p:sp>
+          <p:nvSpPr>
+            <p:cNvPr id="10" name="矩形: 圆角 9">
+              <a:extLst>
+                <a:ext uri="{FF2B5EF4-FFF2-40B4-BE49-F238E27FC236}">
+                  <a16:creationId xmlns:a16="http://schemas.microsoft.com/office/drawing/2014/main" id="{36DA9552-0A65-2DB5-4F9D-452AE2B5296C}"/>
+                </a:ext>
+              </a:extLst>
+            </p:cNvPr>
+            <p:cNvSpPr/>
+            <p:nvPr/>
+          </p:nvSpPr>
+          <p:spPr>
+            <a:xfrm>
+              <a:off x="7522269" y="1371191"/>
+              <a:ext cx="505170" cy="544949"/>
+            </a:xfrm>
+            <a:prstGeom prst="roundRect">
+              <a:avLst>
+                <a:gd name="adj" fmla="val 9697"/>
+              </a:avLst>
+            </a:prstGeom>
+            <a:solidFill>
+              <a:schemeClr val="accent2">
+                <a:lumMod val="40000"/>
+                <a:lumOff val="60000"/>
+                <a:alpha val="30196"/>
+              </a:schemeClr>
+            </a:solidFill>
+            <a:ln>
+              <a:noFill/>
+            </a:ln>
+          </p:spPr>
+          <p:style>
+            <a:lnRef idx="2">
+              <a:schemeClr val="accent1">
+                <a:shade val="50000"/>
+              </a:schemeClr>
+            </a:lnRef>
+            <a:fillRef idx="1">
+              <a:schemeClr val="accent1"/>
+            </a:fillRef>
+            <a:effectRef idx="0">
+              <a:schemeClr val="accent1"/>
+            </a:effectRef>
+            <a:fontRef idx="minor">
+              <a:schemeClr val="lt1"/>
+            </a:fontRef>
+          </p:style>
+          <p:txBody>
+            <a:bodyPr lIns="36000" tIns="36000" rIns="36000" bIns="36000" rtlCol="0" anchor="b"/>
+            <a:lstStyle/>
+            <a:p>
+              <a:pPr algn="ctr"/>
+              <a:endParaRPr lang="zh-CN" altLang="en-US" sz="800" b="1" dirty="0">
+                <a:solidFill>
+                  <a:srgbClr val="00B0F0"/>
+                </a:solidFill>
+              </a:endParaRPr>
+            </a:p>
+          </p:txBody>
+        </p:sp>
+        <p:sp>
+          <p:nvSpPr>
+            <p:cNvPr id="11" name="矩形: 圆角 10">
+              <a:extLst>
+                <a:ext uri="{FF2B5EF4-FFF2-40B4-BE49-F238E27FC236}">
+                  <a16:creationId xmlns:a16="http://schemas.microsoft.com/office/drawing/2014/main" id="{47B466C6-320E-AE43-245F-66CDCD0C748E}"/>
+                </a:ext>
+              </a:extLst>
+            </p:cNvPr>
+            <p:cNvSpPr/>
+            <p:nvPr/>
+          </p:nvSpPr>
+          <p:spPr>
+            <a:xfrm>
+              <a:off x="8338872" y="1371191"/>
+              <a:ext cx="505170" cy="544949"/>
+            </a:xfrm>
+            <a:prstGeom prst="roundRect">
+              <a:avLst>
+                <a:gd name="adj" fmla="val 9697"/>
+              </a:avLst>
+            </a:prstGeom>
+            <a:solidFill>
+              <a:schemeClr val="accent2">
+                <a:lumMod val="40000"/>
+                <a:lumOff val="60000"/>
+                <a:alpha val="30196"/>
+              </a:schemeClr>
+            </a:solidFill>
+            <a:ln>
+              <a:noFill/>
+            </a:ln>
+          </p:spPr>
+          <p:style>
+            <a:lnRef idx="2">
+              <a:schemeClr val="accent1">
+                <a:shade val="50000"/>
+              </a:schemeClr>
+            </a:lnRef>
+            <a:fillRef idx="1">
+              <a:schemeClr val="accent1"/>
+            </a:fillRef>
+            <a:effectRef idx="0">
+              <a:schemeClr val="accent1"/>
+            </a:effectRef>
+            <a:fontRef idx="minor">
+              <a:schemeClr val="lt1"/>
+            </a:fontRef>
+          </p:style>
+          <p:txBody>
+            <a:bodyPr lIns="36000" tIns="36000" rIns="36000" bIns="36000" rtlCol="0" anchor="b"/>
+            <a:lstStyle/>
+            <a:p>
+              <a:pPr algn="ctr"/>
+              <a:endParaRPr lang="zh-CN" altLang="en-US" sz="800" b="1" dirty="0">
+                <a:solidFill>
+                  <a:srgbClr val="00B0F0"/>
+                </a:solidFill>
+              </a:endParaRPr>
+            </a:p>
+          </p:txBody>
+        </p:sp>
+        <p:sp>
+          <p:nvSpPr>
+            <p:cNvPr id="12" name="矩形: 圆角 11">
+              <a:extLst>
+                <a:ext uri="{FF2B5EF4-FFF2-40B4-BE49-F238E27FC236}">
+                  <a16:creationId xmlns:a16="http://schemas.microsoft.com/office/drawing/2014/main" id="{FB7BC93E-5012-6276-6DE1-06FED16E2A1B}"/>
+                </a:ext>
+              </a:extLst>
+            </p:cNvPr>
+            <p:cNvSpPr/>
+            <p:nvPr/>
+          </p:nvSpPr>
+          <p:spPr>
+            <a:xfrm>
+              <a:off x="9155476" y="1371191"/>
+              <a:ext cx="505170" cy="544949"/>
+            </a:xfrm>
+            <a:prstGeom prst="roundRect">
+              <a:avLst>
+                <a:gd name="adj" fmla="val 9697"/>
+              </a:avLst>
+            </a:prstGeom>
+            <a:solidFill>
+              <a:schemeClr val="accent2">
+                <a:lumMod val="40000"/>
+                <a:lumOff val="60000"/>
+                <a:alpha val="30196"/>
+              </a:schemeClr>
+            </a:solidFill>
+            <a:ln>
+              <a:noFill/>
+            </a:ln>
+          </p:spPr>
+          <p:style>
+            <a:lnRef idx="2">
+              <a:schemeClr val="accent1">
+                <a:shade val="50000"/>
+              </a:schemeClr>
+            </a:lnRef>
+            <a:fillRef idx="1">
+              <a:schemeClr val="accent1"/>
+            </a:fillRef>
+            <a:effectRef idx="0">
+              <a:schemeClr val="accent1"/>
+            </a:effectRef>
+            <a:fontRef idx="minor">
+              <a:schemeClr val="lt1"/>
+            </a:fontRef>
+          </p:style>
+          <p:txBody>
+            <a:bodyPr lIns="36000" tIns="36000" rIns="36000" bIns="36000" rtlCol="0" anchor="b"/>
+            <a:lstStyle/>
+            <a:p>
+              <a:pPr algn="ctr"/>
+              <a:endParaRPr lang="zh-CN" altLang="en-US" sz="800" b="1" dirty="0">
+                <a:solidFill>
+                  <a:srgbClr val="00B0F0"/>
+                </a:solidFill>
+              </a:endParaRPr>
+            </a:p>
+          </p:txBody>
+        </p:sp>
+        <p:sp>
+          <p:nvSpPr>
+            <p:cNvPr id="16" name="文本框 15">
+              <a:extLst>
+                <a:ext uri="{FF2B5EF4-FFF2-40B4-BE49-F238E27FC236}">
+                  <a16:creationId xmlns:a16="http://schemas.microsoft.com/office/drawing/2014/main" id="{C1B0FB5F-DD89-636F-E460-04C30E50A59F}"/>
+                </a:ext>
+              </a:extLst>
+            </p:cNvPr>
+            <p:cNvSpPr txBox="1"/>
+            <p:nvPr/>
+          </p:nvSpPr>
+          <p:spPr>
+            <a:xfrm>
+              <a:off x="5242184" y="836823"/>
+              <a:ext cx="938513" cy="534368"/>
+            </a:xfrm>
+            <a:prstGeom prst="rect">
+              <a:avLst/>
+            </a:prstGeom>
+            <a:noFill/>
+          </p:spPr>
+          <p:txBody>
+            <a:bodyPr wrap="square" lIns="36000" tIns="36000" rIns="36000" bIns="36000" rtlCol="0">
+              <a:spAutoFit/>
+            </a:bodyPr>
+            <a:lstStyle/>
+            <a:p>
+              <a:pPr algn="ctr">
+                <a:lnSpc>
+                  <a:spcPts val="1800"/>
+                </a:lnSpc>
+              </a:pPr>
+              <a:r>
+                <a:rPr lang="en-US" altLang="zh-CN" sz="1600" b="1" dirty="0">
+                  <a:solidFill>
+                    <a:schemeClr val="accent2">
+                      <a:lumMod val="75000"/>
+                    </a:schemeClr>
+                  </a:solidFill>
+                </a:rPr>
+                <a:t>Factory Reset</a:t>
+              </a:r>
+              <a:endParaRPr lang="zh-CN" altLang="en-US" sz="1600" b="1" dirty="0">
+                <a:solidFill>
+                  <a:schemeClr val="accent2">
+                    <a:lumMod val="75000"/>
+                  </a:schemeClr>
+                </a:solidFill>
+              </a:endParaRPr>
+            </a:p>
+          </p:txBody>
+        </p:sp>
+        <p:cxnSp>
+          <p:nvCxnSpPr>
+            <p:cNvPr id="38" name="直接连接符 37">
+              <a:extLst>
+                <a:ext uri="{FF2B5EF4-FFF2-40B4-BE49-F238E27FC236}">
+                  <a16:creationId xmlns:a16="http://schemas.microsoft.com/office/drawing/2014/main" id="{B56BFFA6-EA5B-D731-4BCA-1A24DB9D2D1D}"/>
+                </a:ext>
+              </a:extLst>
+            </p:cNvPr>
+            <p:cNvCxnSpPr>
+              <a:cxnSpLocks/>
+              <a:stCxn id="9" idx="0"/>
+            </p:cNvCxnSpPr>
+            <p:nvPr/>
+          </p:nvCxnSpPr>
+          <p:spPr>
+            <a:xfrm flipH="1" flipV="1">
+              <a:off x="6958013" y="1135416"/>
+              <a:ext cx="238" cy="235775"/>
+            </a:xfrm>
+            <a:prstGeom prst="line">
+              <a:avLst/>
+            </a:prstGeom>
+            <a:ln w="28575">
+              <a:solidFill>
+                <a:schemeClr val="accent2">
+                  <a:lumMod val="75000"/>
+                </a:schemeClr>
+              </a:solidFill>
+              <a:prstDash val="sysDot"/>
+            </a:ln>
+          </p:spPr>
+          <p:style>
+            <a:lnRef idx="1">
+              <a:schemeClr val="accent1"/>
+            </a:lnRef>
+            <a:fillRef idx="0">
+              <a:schemeClr val="accent1"/>
+            </a:fillRef>
+            <a:effectRef idx="0">
+              <a:schemeClr val="accent1"/>
+            </a:effectRef>
+            <a:fontRef idx="minor">
+              <a:schemeClr val="tx1"/>
+            </a:fontRef>
+          </p:style>
+        </p:cxnSp>
+        <p:cxnSp>
+          <p:nvCxnSpPr>
+            <p:cNvPr id="40" name="直接连接符 39">
+              <a:extLst>
+                <a:ext uri="{FF2B5EF4-FFF2-40B4-BE49-F238E27FC236}">
+                  <a16:creationId xmlns:a16="http://schemas.microsoft.com/office/drawing/2014/main" id="{27FB53EF-C49E-2088-CF70-AC7D99B873AD}"/>
+                </a:ext>
+              </a:extLst>
+            </p:cNvPr>
+            <p:cNvCxnSpPr>
+              <a:cxnSpLocks/>
+              <a:stCxn id="10" idx="0"/>
+            </p:cNvCxnSpPr>
+            <p:nvPr/>
+          </p:nvCxnSpPr>
+          <p:spPr>
+            <a:xfrm flipH="1" flipV="1">
+              <a:off x="7772037" y="1135416"/>
+              <a:ext cx="2817" cy="235775"/>
+            </a:xfrm>
+            <a:prstGeom prst="line">
+              <a:avLst/>
+            </a:prstGeom>
+            <a:ln w="28575">
+              <a:solidFill>
+                <a:schemeClr val="accent2">
+                  <a:lumMod val="75000"/>
+                </a:schemeClr>
+              </a:solidFill>
+              <a:prstDash val="sysDot"/>
+            </a:ln>
+          </p:spPr>
+          <p:style>
+            <a:lnRef idx="1">
+              <a:schemeClr val="accent1"/>
+            </a:lnRef>
+            <a:fillRef idx="0">
+              <a:schemeClr val="accent1"/>
+            </a:fillRef>
+            <a:effectRef idx="0">
+              <a:schemeClr val="accent1"/>
+            </a:effectRef>
+            <a:fontRef idx="minor">
+              <a:schemeClr val="tx1"/>
+            </a:fontRef>
+          </p:style>
+        </p:cxnSp>
+        <p:cxnSp>
+          <p:nvCxnSpPr>
+            <p:cNvPr id="42" name="直接连接符 41">
+              <a:extLst>
+                <a:ext uri="{FF2B5EF4-FFF2-40B4-BE49-F238E27FC236}">
+                  <a16:creationId xmlns:a16="http://schemas.microsoft.com/office/drawing/2014/main" id="{F48D3B24-6F74-1D6D-FF26-A1244A84A758}"/>
+                </a:ext>
+              </a:extLst>
+            </p:cNvPr>
+            <p:cNvCxnSpPr>
+              <a:cxnSpLocks/>
+              <a:stCxn id="11" idx="0"/>
+            </p:cNvCxnSpPr>
+            <p:nvPr/>
+          </p:nvCxnSpPr>
+          <p:spPr>
+            <a:xfrm flipH="1" flipV="1">
+              <a:off x="8588640" y="1135416"/>
+              <a:ext cx="2817" cy="235775"/>
+            </a:xfrm>
+            <a:prstGeom prst="line">
+              <a:avLst/>
+            </a:prstGeom>
+            <a:ln w="28575">
+              <a:solidFill>
+                <a:schemeClr val="accent2">
+                  <a:lumMod val="75000"/>
+                </a:schemeClr>
+              </a:solidFill>
+              <a:prstDash val="sysDot"/>
+            </a:ln>
+          </p:spPr>
+          <p:style>
+            <a:lnRef idx="1">
+              <a:schemeClr val="accent1"/>
+            </a:lnRef>
+            <a:fillRef idx="0">
+              <a:schemeClr val="accent1"/>
+            </a:fillRef>
+            <a:effectRef idx="0">
+              <a:schemeClr val="accent1"/>
+            </a:effectRef>
+            <a:fontRef idx="minor">
+              <a:schemeClr val="tx1"/>
+            </a:fontRef>
+          </p:style>
+        </p:cxnSp>
+      </p:grpSp>
     </p:spTree>
     <p:extLst>
       <p:ext uri="{BB962C8B-B14F-4D97-AF65-F5344CB8AC3E}">

</xml_diff>